<commit_message>
Update presentation to clarify product scope and usage frequency
Update slides to explicitly state the product handles 180 strategic situations and activates 15-20 times annually, resolving conflicting metrics and clarifying scope.

Replit-Commit-Author: Agent
Replit-Commit-Session-Id: 85f09f3c-352d-446d-b98e-3f307c26fc5a
Replit-Commit-Checkpoint-Type: full_checkpoint
Replit-Commit-Event-Id: 7b741e26-16c0-474c-a7e8-eccbe0a0afc2
Replit-Commit-Screenshot-Url: https://storage.googleapis.com/screenshot-production-us-central1/3bd53afc-ff4f-401b-9e3d-b367791ef629/85f09f3c-352d-446d-b98e-3f307c26fc5a/gx3x3B6
Replit-Helium-Checkpoint-Created: true
</commit_message>
<xml_diff>
--- a/attached_assets/readiness_os_vc_pitch_v2.pptx
+++ b/attached_assets/readiness_os_vc_pitch_v2.pptx
@@ -8974,7 +8974,7 @@
                 <a:ea typeface="Cambria" pitchFamily="34" charset="-122"/>
                 <a:cs typeface="Cambria" pitchFamily="34" charset="-120"/>
               </a:rPr>
-              <a:t>And this happens every time a situation presents itself — 15–20 times every year.</a:t>
+              <a:t>This cycle repeats 15–20 times every year in any enterprise — across 180 documented strategic situations. Every single one an unscripted improvisation.</a:t>
             </a:r>
             <a:endParaRPr lang="en-US" sz="1300" dirty="0"/>
           </a:p>
@@ -10482,7 +10482,7 @@
                 <a:ea typeface="Calibri" pitchFamily="34" charset="-122"/>
                 <a:cs typeface="Calibri" pitchFamily="34" charset="-120"/>
               </a:rPr>
-              <a:t>4–6 strategic situations each per year</a:t>
+              <a:t>15–20 strategic situations annually (conservative: 4–6)</a:t>
             </a:r>
             <a:endParaRPr lang="en-US" sz="1000" dirty="0"/>
           </a:p>
@@ -10597,7 +10597,7 @@
                 <a:ea typeface="Cambria" pitchFamily="34" charset="-122"/>
                 <a:cs typeface="Cambria" pitchFamily="34" charset="-120"/>
               </a:rPr>
-              <a:t>4–6</a:t>
+              <a:t>15–20</a:t>
             </a:r>
             <a:endParaRPr lang="en-US" sz="4800" dirty="0"/>
           </a:p>

</xml_diff>

<commit_message>
Update investor deck title and finalize presentation
Update the title of the investor deck to indicate it is the final version and upload the revised PowerPoint presentation.

Replit-Commit-Author: Agent
Replit-Commit-Session-Id: 85f09f3c-352d-446d-b98e-3f307c26fc5a
Replit-Commit-Checkpoint-Type: full_checkpoint
Replit-Commit-Event-Id: 161011f6-1a14-4698-adc4-94dbb9b7a370
Replit-Commit-Screenshot-Url: https://storage.googleapis.com/screenshot-production-us-central1/3bd53afc-ff4f-401b-9e3d-b367791ef629/85f09f3c-352d-446d-b98e-3f307c26fc5a/gx3x3B6
Replit-Helium-Checkpoint-Created: true
</commit_message>
<xml_diff>
--- a/attached_assets/readiness_os_vc_pitch_v2.pptx
+++ b/attached_assets/readiness_os_vc_pitch_v2.pptx
@@ -21003,2611 +21003,453 @@
       </p:grpSpPr>
       <p:sp>
         <p:nvSpPr>
-          <p:cNvPr id="2" name="Shape 0"/>
+          <p:cNvPr id="2" name="Rectangle 1"/>
           <p:cNvSpPr/>
           <p:nvPr/>
         </p:nvSpPr>
         <p:spPr>
           <a:xfrm>
             <a:off x="0" y="0"/>
-            <a:ext cx="0" cy="5143500"/>
-          </a:xfrm>
-          <a:prstGeom prst="line">
-            <a:avLst/>
-          </a:prstGeom>
-          <a:noFill/>
-          <a:ln w="3810">
-            <a:solidFill>
-              <a:srgbClr val="C9A84C">
-                <a:alpha val="7000"/>
-              </a:srgbClr>
-            </a:solidFill>
-            <a:prstDash val="solid"/>
-          </a:ln>
-        </p:spPr>
-        <p:txBody>
-          <a:bodyPr/>
-          <a:p/>
-        </p:txBody>
-      </p:sp>
-      <p:sp>
-        <p:nvSpPr>
-          <p:cNvPr id="3" name="Shape 1"/>
-          <p:cNvSpPr/>
-          <p:nvPr/>
-        </p:nvSpPr>
-        <p:spPr>
-          <a:xfrm>
-            <a:off x="457200" y="0"/>
-            <a:ext cx="0" cy="5143500"/>
-          </a:xfrm>
-          <a:prstGeom prst="line">
-            <a:avLst/>
-          </a:prstGeom>
-          <a:noFill/>
-          <a:ln w="3810">
-            <a:solidFill>
-              <a:srgbClr val="C9A84C">
-                <a:alpha val="7000"/>
-              </a:srgbClr>
-            </a:solidFill>
-            <a:prstDash val="solid"/>
-          </a:ln>
-        </p:spPr>
-        <p:txBody>
-          <a:bodyPr/>
-          <a:p/>
-        </p:txBody>
-      </p:sp>
-      <p:sp>
-        <p:nvSpPr>
-          <p:cNvPr id="4" name="Shape 2"/>
-          <p:cNvSpPr/>
-          <p:nvPr/>
-        </p:nvSpPr>
-        <p:spPr>
-          <a:xfrm>
-            <a:off x="914400" y="0"/>
-            <a:ext cx="0" cy="5143500"/>
-          </a:xfrm>
-          <a:prstGeom prst="line">
-            <a:avLst/>
-          </a:prstGeom>
-          <a:noFill/>
-          <a:ln w="3810">
-            <a:solidFill>
-              <a:srgbClr val="C9A84C">
-                <a:alpha val="7000"/>
-              </a:srgbClr>
-            </a:solidFill>
-            <a:prstDash val="solid"/>
-          </a:ln>
-        </p:spPr>
-        <p:txBody>
-          <a:bodyPr/>
-          <a:p/>
-        </p:txBody>
-      </p:sp>
-      <p:sp>
-        <p:nvSpPr>
-          <p:cNvPr id="5" name="Shape 3"/>
-          <p:cNvSpPr/>
-          <p:nvPr/>
-        </p:nvSpPr>
-        <p:spPr>
-          <a:xfrm>
-            <a:off x="1371600" y="0"/>
-            <a:ext cx="0" cy="5143500"/>
-          </a:xfrm>
-          <a:prstGeom prst="line">
-            <a:avLst/>
-          </a:prstGeom>
-          <a:noFill/>
-          <a:ln w="3810">
-            <a:solidFill>
-              <a:srgbClr val="C9A84C">
-                <a:alpha val="7000"/>
-              </a:srgbClr>
-            </a:solidFill>
-            <a:prstDash val="solid"/>
-          </a:ln>
-        </p:spPr>
-        <p:txBody>
-          <a:bodyPr/>
-          <a:p/>
-        </p:txBody>
-      </p:sp>
-      <p:sp>
-        <p:nvSpPr>
-          <p:cNvPr id="6" name="Shape 4"/>
-          <p:cNvSpPr/>
-          <p:nvPr/>
-        </p:nvSpPr>
-        <p:spPr>
-          <a:xfrm>
-            <a:off x="1828800" y="0"/>
-            <a:ext cx="0" cy="5143500"/>
-          </a:xfrm>
-          <a:prstGeom prst="line">
-            <a:avLst/>
-          </a:prstGeom>
-          <a:noFill/>
-          <a:ln w="3810">
-            <a:solidFill>
-              <a:srgbClr val="C9A84C">
-                <a:alpha val="7000"/>
-              </a:srgbClr>
-            </a:solidFill>
-            <a:prstDash val="solid"/>
-          </a:ln>
-        </p:spPr>
-        <p:txBody>
-          <a:bodyPr/>
-          <a:p/>
-        </p:txBody>
-      </p:sp>
-      <p:sp>
-        <p:nvSpPr>
-          <p:cNvPr id="7" name="Shape 5"/>
-          <p:cNvSpPr/>
-          <p:nvPr/>
-        </p:nvSpPr>
-        <p:spPr>
-          <a:xfrm>
-            <a:off x="2286000" y="0"/>
-            <a:ext cx="0" cy="5143500"/>
-          </a:xfrm>
-          <a:prstGeom prst="line">
-            <a:avLst/>
-          </a:prstGeom>
-          <a:noFill/>
-          <a:ln w="3810">
-            <a:solidFill>
-              <a:srgbClr val="C9A84C">
-                <a:alpha val="7000"/>
-              </a:srgbClr>
-            </a:solidFill>
-            <a:prstDash val="solid"/>
-          </a:ln>
-        </p:spPr>
-        <p:txBody>
-          <a:bodyPr/>
-          <a:p/>
-        </p:txBody>
-      </p:sp>
-      <p:sp>
-        <p:nvSpPr>
-          <p:cNvPr id="8" name="Shape 6"/>
-          <p:cNvSpPr/>
-          <p:nvPr/>
-        </p:nvSpPr>
-        <p:spPr>
-          <a:xfrm>
-            <a:off x="2743200" y="0"/>
-            <a:ext cx="0" cy="5143500"/>
-          </a:xfrm>
-          <a:prstGeom prst="line">
-            <a:avLst/>
-          </a:prstGeom>
-          <a:noFill/>
-          <a:ln w="3810">
-            <a:solidFill>
-              <a:srgbClr val="C9A84C">
-                <a:alpha val="7000"/>
-              </a:srgbClr>
-            </a:solidFill>
-            <a:prstDash val="solid"/>
-          </a:ln>
-        </p:spPr>
-        <p:txBody>
-          <a:bodyPr/>
-          <a:p/>
-        </p:txBody>
-      </p:sp>
-      <p:sp>
-        <p:nvSpPr>
-          <p:cNvPr id="9" name="Shape 7"/>
-          <p:cNvSpPr/>
-          <p:nvPr/>
-        </p:nvSpPr>
-        <p:spPr>
-          <a:xfrm>
-            <a:off x="3200400" y="0"/>
-            <a:ext cx="0" cy="5143500"/>
-          </a:xfrm>
-          <a:prstGeom prst="line">
-            <a:avLst/>
-          </a:prstGeom>
-          <a:noFill/>
-          <a:ln w="3810">
-            <a:solidFill>
-              <a:srgbClr val="C9A84C">
-                <a:alpha val="7000"/>
-              </a:srgbClr>
-            </a:solidFill>
-            <a:prstDash val="solid"/>
-          </a:ln>
-        </p:spPr>
-        <p:txBody>
-          <a:bodyPr/>
-          <a:p/>
-        </p:txBody>
-      </p:sp>
-      <p:sp>
-        <p:nvSpPr>
-          <p:cNvPr id="10" name="Shape 8"/>
-          <p:cNvSpPr/>
-          <p:nvPr/>
-        </p:nvSpPr>
-        <p:spPr>
-          <a:xfrm>
-            <a:off x="3657600" y="0"/>
-            <a:ext cx="0" cy="5143500"/>
-          </a:xfrm>
-          <a:prstGeom prst="line">
-            <a:avLst/>
-          </a:prstGeom>
-          <a:noFill/>
-          <a:ln w="3810">
-            <a:solidFill>
-              <a:srgbClr val="C9A84C">
-                <a:alpha val="7000"/>
-              </a:srgbClr>
-            </a:solidFill>
-            <a:prstDash val="solid"/>
-          </a:ln>
-        </p:spPr>
-        <p:txBody>
-          <a:bodyPr/>
-          <a:p/>
-        </p:txBody>
-      </p:sp>
-      <p:sp>
-        <p:nvSpPr>
-          <p:cNvPr id="11" name="Shape 9"/>
-          <p:cNvSpPr/>
-          <p:nvPr/>
-        </p:nvSpPr>
-        <p:spPr>
-          <a:xfrm>
-            <a:off x="4114800" y="0"/>
-            <a:ext cx="0" cy="5143500"/>
-          </a:xfrm>
-          <a:prstGeom prst="line">
-            <a:avLst/>
-          </a:prstGeom>
-          <a:noFill/>
-          <a:ln w="3810">
-            <a:solidFill>
-              <a:srgbClr val="C9A84C">
-                <a:alpha val="7000"/>
-              </a:srgbClr>
-            </a:solidFill>
-            <a:prstDash val="solid"/>
-          </a:ln>
-        </p:spPr>
-        <p:txBody>
-          <a:bodyPr/>
-          <a:p/>
-        </p:txBody>
-      </p:sp>
-      <p:sp>
-        <p:nvSpPr>
-          <p:cNvPr id="12" name="Shape 10"/>
-          <p:cNvSpPr/>
-          <p:nvPr/>
-        </p:nvSpPr>
-        <p:spPr>
-          <a:xfrm>
-            <a:off x="4572000" y="0"/>
-            <a:ext cx="0" cy="5143500"/>
-          </a:xfrm>
-          <a:prstGeom prst="line">
-            <a:avLst/>
-          </a:prstGeom>
-          <a:noFill/>
-          <a:ln w="3810">
-            <a:solidFill>
-              <a:srgbClr val="C9A84C">
-                <a:alpha val="7000"/>
-              </a:srgbClr>
-            </a:solidFill>
-            <a:prstDash val="solid"/>
-          </a:ln>
-        </p:spPr>
-        <p:txBody>
-          <a:bodyPr/>
-          <a:p/>
-        </p:txBody>
-      </p:sp>
-      <p:sp>
-        <p:nvSpPr>
-          <p:cNvPr id="13" name="Shape 11"/>
-          <p:cNvSpPr/>
-          <p:nvPr/>
-        </p:nvSpPr>
-        <p:spPr>
-          <a:xfrm>
-            <a:off x="5029200" y="0"/>
-            <a:ext cx="0" cy="5143500"/>
-          </a:xfrm>
-          <a:prstGeom prst="line">
-            <a:avLst/>
-          </a:prstGeom>
-          <a:noFill/>
-          <a:ln w="3810">
-            <a:solidFill>
-              <a:srgbClr val="C9A84C">
-                <a:alpha val="7000"/>
-              </a:srgbClr>
-            </a:solidFill>
-            <a:prstDash val="solid"/>
-          </a:ln>
-        </p:spPr>
-        <p:txBody>
-          <a:bodyPr/>
-          <a:p/>
-        </p:txBody>
-      </p:sp>
-      <p:sp>
-        <p:nvSpPr>
-          <p:cNvPr id="14" name="Shape 12"/>
-          <p:cNvSpPr/>
-          <p:nvPr/>
-        </p:nvSpPr>
-        <p:spPr>
-          <a:xfrm>
-            <a:off x="5486400" y="0"/>
-            <a:ext cx="0" cy="5143500"/>
-          </a:xfrm>
-          <a:prstGeom prst="line">
-            <a:avLst/>
-          </a:prstGeom>
-          <a:noFill/>
-          <a:ln w="3810">
-            <a:solidFill>
-              <a:srgbClr val="C9A84C">
-                <a:alpha val="7000"/>
-              </a:srgbClr>
-            </a:solidFill>
-            <a:prstDash val="solid"/>
-          </a:ln>
-        </p:spPr>
-        <p:txBody>
-          <a:bodyPr/>
-          <a:p/>
-        </p:txBody>
-      </p:sp>
-      <p:sp>
-        <p:nvSpPr>
-          <p:cNvPr id="15" name="Shape 13"/>
-          <p:cNvSpPr/>
-          <p:nvPr/>
-        </p:nvSpPr>
-        <p:spPr>
-          <a:xfrm>
-            <a:off x="5943600" y="0"/>
-            <a:ext cx="0" cy="5143500"/>
-          </a:xfrm>
-          <a:prstGeom prst="line">
-            <a:avLst/>
-          </a:prstGeom>
-          <a:noFill/>
-          <a:ln w="3810">
-            <a:solidFill>
-              <a:srgbClr val="C9A84C">
-                <a:alpha val="7000"/>
-              </a:srgbClr>
-            </a:solidFill>
-            <a:prstDash val="solid"/>
-          </a:ln>
-        </p:spPr>
-        <p:txBody>
-          <a:bodyPr/>
-          <a:p/>
-        </p:txBody>
-      </p:sp>
-      <p:sp>
-        <p:nvSpPr>
-          <p:cNvPr id="16" name="Shape 14"/>
-          <p:cNvSpPr/>
-          <p:nvPr/>
-        </p:nvSpPr>
-        <p:spPr>
-          <a:xfrm>
-            <a:off x="6400800" y="0"/>
-            <a:ext cx="0" cy="5143500"/>
-          </a:xfrm>
-          <a:prstGeom prst="line">
-            <a:avLst/>
-          </a:prstGeom>
-          <a:noFill/>
-          <a:ln w="3810">
-            <a:solidFill>
-              <a:srgbClr val="C9A84C">
-                <a:alpha val="7000"/>
-              </a:srgbClr>
-            </a:solidFill>
-            <a:prstDash val="solid"/>
-          </a:ln>
-        </p:spPr>
-        <p:txBody>
-          <a:bodyPr/>
-          <a:p/>
-        </p:txBody>
-      </p:sp>
-      <p:sp>
-        <p:nvSpPr>
-          <p:cNvPr id="17" name="Shape 15"/>
-          <p:cNvSpPr/>
-          <p:nvPr/>
-        </p:nvSpPr>
-        <p:spPr>
-          <a:xfrm>
-            <a:off x="6858000" y="0"/>
-            <a:ext cx="0" cy="5143500"/>
-          </a:xfrm>
-          <a:prstGeom prst="line">
-            <a:avLst/>
-          </a:prstGeom>
-          <a:noFill/>
-          <a:ln w="3810">
-            <a:solidFill>
-              <a:srgbClr val="C9A84C">
-                <a:alpha val="7000"/>
-              </a:srgbClr>
-            </a:solidFill>
-            <a:prstDash val="solid"/>
-          </a:ln>
-        </p:spPr>
-        <p:txBody>
-          <a:bodyPr/>
-          <a:p/>
-        </p:txBody>
-      </p:sp>
-      <p:sp>
-        <p:nvSpPr>
-          <p:cNvPr id="18" name="Shape 16"/>
-          <p:cNvSpPr/>
-          <p:nvPr/>
-        </p:nvSpPr>
-        <p:spPr>
-          <a:xfrm>
-            <a:off x="7315200" y="0"/>
-            <a:ext cx="0" cy="5143500"/>
-          </a:xfrm>
-          <a:prstGeom prst="line">
-            <a:avLst/>
-          </a:prstGeom>
-          <a:noFill/>
-          <a:ln w="3810">
-            <a:solidFill>
-              <a:srgbClr val="C9A84C">
-                <a:alpha val="7000"/>
-              </a:srgbClr>
-            </a:solidFill>
-            <a:prstDash val="solid"/>
-          </a:ln>
-        </p:spPr>
-        <p:txBody>
-          <a:bodyPr/>
-          <a:p/>
-        </p:txBody>
-      </p:sp>
-      <p:sp>
-        <p:nvSpPr>
-          <p:cNvPr id="19" name="Shape 17"/>
-          <p:cNvSpPr/>
-          <p:nvPr/>
-        </p:nvSpPr>
-        <p:spPr>
-          <a:xfrm>
-            <a:off x="7772400" y="0"/>
-            <a:ext cx="0" cy="5143500"/>
-          </a:xfrm>
-          <a:prstGeom prst="line">
-            <a:avLst/>
-          </a:prstGeom>
-          <a:noFill/>
-          <a:ln w="3810">
-            <a:solidFill>
-              <a:srgbClr val="C9A84C">
-                <a:alpha val="7000"/>
-              </a:srgbClr>
-            </a:solidFill>
-            <a:prstDash val="solid"/>
-          </a:ln>
-        </p:spPr>
-        <p:txBody>
-          <a:bodyPr/>
-          <a:p/>
-        </p:txBody>
-      </p:sp>
-      <p:sp>
-        <p:nvSpPr>
-          <p:cNvPr id="20" name="Shape 18"/>
-          <p:cNvSpPr/>
-          <p:nvPr/>
-        </p:nvSpPr>
-        <p:spPr>
-          <a:xfrm>
-            <a:off x="8229600" y="0"/>
-            <a:ext cx="0" cy="5143500"/>
-          </a:xfrm>
-          <a:prstGeom prst="line">
-            <a:avLst/>
-          </a:prstGeom>
-          <a:noFill/>
-          <a:ln w="3810">
-            <a:solidFill>
-              <a:srgbClr val="C9A84C">
-                <a:alpha val="7000"/>
-              </a:srgbClr>
-            </a:solidFill>
-            <a:prstDash val="solid"/>
-          </a:ln>
-        </p:spPr>
-        <p:txBody>
-          <a:bodyPr/>
-          <a:p/>
-        </p:txBody>
-      </p:sp>
-      <p:sp>
-        <p:nvSpPr>
-          <p:cNvPr id="21" name="Shape 19"/>
-          <p:cNvSpPr/>
-          <p:nvPr/>
-        </p:nvSpPr>
-        <p:spPr>
-          <a:xfrm>
-            <a:off x="8686800" y="0"/>
-            <a:ext cx="0" cy="5143500"/>
-          </a:xfrm>
-          <a:prstGeom prst="line">
-            <a:avLst/>
-          </a:prstGeom>
-          <a:noFill/>
-          <a:ln w="3810">
-            <a:solidFill>
-              <a:srgbClr val="C9A84C">
-                <a:alpha val="7000"/>
-              </a:srgbClr>
-            </a:solidFill>
-            <a:prstDash val="solid"/>
-          </a:ln>
-        </p:spPr>
-        <p:txBody>
-          <a:bodyPr/>
-          <a:p/>
-        </p:txBody>
-      </p:sp>
-      <p:sp>
-        <p:nvSpPr>
-          <p:cNvPr id="22" name="Shape 20"/>
-          <p:cNvSpPr/>
-          <p:nvPr/>
-        </p:nvSpPr>
-        <p:spPr>
-          <a:xfrm>
-            <a:off x="9144000" y="0"/>
-            <a:ext cx="0" cy="5143500"/>
-          </a:xfrm>
-          <a:prstGeom prst="line">
-            <a:avLst/>
-          </a:prstGeom>
-          <a:noFill/>
-          <a:ln w="3810">
-            <a:solidFill>
-              <a:srgbClr val="C9A84C">
-                <a:alpha val="7000"/>
-              </a:srgbClr>
-            </a:solidFill>
-            <a:prstDash val="solid"/>
-          </a:ln>
-        </p:spPr>
-        <p:txBody>
-          <a:bodyPr/>
-          <a:p/>
-        </p:txBody>
-      </p:sp>
-      <p:sp>
-        <p:nvSpPr>
-          <p:cNvPr id="23" name="Shape 21"/>
-          <p:cNvSpPr/>
-          <p:nvPr/>
-        </p:nvSpPr>
-        <p:spPr>
-          <a:xfrm>
-            <a:off x="0" y="0"/>
-            <a:ext cx="9144000" cy="0"/>
-          </a:xfrm>
-          <a:prstGeom prst="line">
-            <a:avLst/>
-          </a:prstGeom>
-          <a:noFill/>
-          <a:ln w="3810">
-            <a:solidFill>
-              <a:srgbClr val="C9A84C">
-                <a:alpha val="7000"/>
-              </a:srgbClr>
-            </a:solidFill>
-            <a:prstDash val="solid"/>
-          </a:ln>
-        </p:spPr>
-        <p:txBody>
-          <a:bodyPr/>
-          <a:p/>
-        </p:txBody>
-      </p:sp>
-      <p:sp>
-        <p:nvSpPr>
-          <p:cNvPr id="24" name="Shape 22"/>
-          <p:cNvSpPr/>
-          <p:nvPr/>
-        </p:nvSpPr>
-        <p:spPr>
-          <a:xfrm>
-            <a:off x="0" y="457200"/>
-            <a:ext cx="9144000" cy="0"/>
-          </a:xfrm>
-          <a:prstGeom prst="line">
-            <a:avLst/>
-          </a:prstGeom>
-          <a:noFill/>
-          <a:ln w="3810">
-            <a:solidFill>
-              <a:srgbClr val="C9A84C">
-                <a:alpha val="7000"/>
-              </a:srgbClr>
-            </a:solidFill>
-            <a:prstDash val="solid"/>
-          </a:ln>
-        </p:spPr>
-        <p:txBody>
-          <a:bodyPr/>
-          <a:p/>
-        </p:txBody>
-      </p:sp>
-      <p:sp>
-        <p:nvSpPr>
-          <p:cNvPr id="25" name="Shape 23"/>
-          <p:cNvSpPr/>
-          <p:nvPr/>
-        </p:nvSpPr>
-        <p:spPr>
-          <a:xfrm>
-            <a:off x="0" y="914400"/>
-            <a:ext cx="9144000" cy="0"/>
-          </a:xfrm>
-          <a:prstGeom prst="line">
-            <a:avLst/>
-          </a:prstGeom>
-          <a:noFill/>
-          <a:ln w="3810">
-            <a:solidFill>
-              <a:srgbClr val="C9A84C">
-                <a:alpha val="7000"/>
-              </a:srgbClr>
-            </a:solidFill>
-            <a:prstDash val="solid"/>
-          </a:ln>
-        </p:spPr>
-        <p:txBody>
-          <a:bodyPr/>
-          <a:p/>
-        </p:txBody>
-      </p:sp>
-      <p:sp>
-        <p:nvSpPr>
-          <p:cNvPr id="26" name="Shape 24"/>
-          <p:cNvSpPr/>
-          <p:nvPr/>
-        </p:nvSpPr>
-        <p:spPr>
-          <a:xfrm>
-            <a:off x="0" y="1371600"/>
-            <a:ext cx="9144000" cy="0"/>
-          </a:xfrm>
-          <a:prstGeom prst="line">
-            <a:avLst/>
-          </a:prstGeom>
-          <a:noFill/>
-          <a:ln w="3810">
-            <a:solidFill>
-              <a:srgbClr val="C9A84C">
-                <a:alpha val="7000"/>
-              </a:srgbClr>
-            </a:solidFill>
-            <a:prstDash val="solid"/>
-          </a:ln>
-        </p:spPr>
-        <p:txBody>
-          <a:bodyPr/>
-          <a:p/>
-        </p:txBody>
-      </p:sp>
-      <p:sp>
-        <p:nvSpPr>
-          <p:cNvPr id="27" name="Shape 25"/>
-          <p:cNvSpPr/>
-          <p:nvPr/>
-        </p:nvSpPr>
-        <p:spPr>
-          <a:xfrm>
-            <a:off x="0" y="1828800"/>
-            <a:ext cx="9144000" cy="0"/>
-          </a:xfrm>
-          <a:prstGeom prst="line">
-            <a:avLst/>
-          </a:prstGeom>
-          <a:noFill/>
-          <a:ln w="3810">
-            <a:solidFill>
-              <a:srgbClr val="C9A84C">
-                <a:alpha val="7000"/>
-              </a:srgbClr>
-            </a:solidFill>
-            <a:prstDash val="solid"/>
-          </a:ln>
-        </p:spPr>
-        <p:txBody>
-          <a:bodyPr/>
-          <a:p/>
-        </p:txBody>
-      </p:sp>
-      <p:sp>
-        <p:nvSpPr>
-          <p:cNvPr id="28" name="Shape 26"/>
-          <p:cNvSpPr/>
-          <p:nvPr/>
-        </p:nvSpPr>
-        <p:spPr>
-          <a:xfrm>
-            <a:off x="0" y="2286000"/>
-            <a:ext cx="9144000" cy="0"/>
-          </a:xfrm>
-          <a:prstGeom prst="line">
-            <a:avLst/>
-          </a:prstGeom>
-          <a:noFill/>
-          <a:ln w="3810">
-            <a:solidFill>
-              <a:srgbClr val="C9A84C">
-                <a:alpha val="7000"/>
-              </a:srgbClr>
-            </a:solidFill>
-            <a:prstDash val="solid"/>
-          </a:ln>
-        </p:spPr>
-        <p:txBody>
-          <a:bodyPr/>
-          <a:p/>
-        </p:txBody>
-      </p:sp>
-      <p:sp>
-        <p:nvSpPr>
-          <p:cNvPr id="29" name="Shape 27"/>
-          <p:cNvSpPr/>
-          <p:nvPr/>
-        </p:nvSpPr>
-        <p:spPr>
-          <a:xfrm>
-            <a:off x="0" y="2743200"/>
-            <a:ext cx="9144000" cy="0"/>
-          </a:xfrm>
-          <a:prstGeom prst="line">
-            <a:avLst/>
-          </a:prstGeom>
-          <a:noFill/>
-          <a:ln w="3810">
-            <a:solidFill>
-              <a:srgbClr val="C9A84C">
-                <a:alpha val="7000"/>
-              </a:srgbClr>
-            </a:solidFill>
-            <a:prstDash val="solid"/>
-          </a:ln>
-        </p:spPr>
-        <p:txBody>
-          <a:bodyPr/>
-          <a:p/>
-        </p:txBody>
-      </p:sp>
-      <p:sp>
-        <p:nvSpPr>
-          <p:cNvPr id="30" name="Shape 28"/>
-          <p:cNvSpPr/>
-          <p:nvPr/>
-        </p:nvSpPr>
-        <p:spPr>
-          <a:xfrm>
-            <a:off x="0" y="3200400"/>
-            <a:ext cx="9144000" cy="0"/>
-          </a:xfrm>
-          <a:prstGeom prst="line">
-            <a:avLst/>
-          </a:prstGeom>
-          <a:noFill/>
-          <a:ln w="3810">
-            <a:solidFill>
-              <a:srgbClr val="C9A84C">
-                <a:alpha val="7000"/>
-              </a:srgbClr>
-            </a:solidFill>
-            <a:prstDash val="solid"/>
-          </a:ln>
-        </p:spPr>
-        <p:txBody>
-          <a:bodyPr/>
-          <a:p/>
-        </p:txBody>
-      </p:sp>
-      <p:sp>
-        <p:nvSpPr>
-          <p:cNvPr id="31" name="Shape 29"/>
-          <p:cNvSpPr/>
-          <p:nvPr/>
-        </p:nvSpPr>
-        <p:spPr>
-          <a:xfrm>
-            <a:off x="0" y="3657600"/>
-            <a:ext cx="9144000" cy="0"/>
-          </a:xfrm>
-          <a:prstGeom prst="line">
-            <a:avLst/>
-          </a:prstGeom>
-          <a:noFill/>
-          <a:ln w="3810">
-            <a:solidFill>
-              <a:srgbClr val="C9A84C">
-                <a:alpha val="7000"/>
-              </a:srgbClr>
-            </a:solidFill>
-            <a:prstDash val="solid"/>
-          </a:ln>
-        </p:spPr>
-        <p:txBody>
-          <a:bodyPr/>
-          <a:p/>
-        </p:txBody>
-      </p:sp>
-      <p:sp>
-        <p:nvSpPr>
-          <p:cNvPr id="32" name="Shape 30"/>
-          <p:cNvSpPr/>
-          <p:nvPr/>
-        </p:nvSpPr>
-        <p:spPr>
-          <a:xfrm>
-            <a:off x="0" y="4114800"/>
-            <a:ext cx="9144000" cy="0"/>
-          </a:xfrm>
-          <a:prstGeom prst="line">
-            <a:avLst/>
-          </a:prstGeom>
-          <a:noFill/>
-          <a:ln w="3810">
-            <a:solidFill>
-              <a:srgbClr val="C9A84C">
-                <a:alpha val="7000"/>
-              </a:srgbClr>
-            </a:solidFill>
-            <a:prstDash val="solid"/>
-          </a:ln>
-        </p:spPr>
-        <p:txBody>
-          <a:bodyPr/>
-          <a:p/>
-        </p:txBody>
-      </p:sp>
-      <p:sp>
-        <p:nvSpPr>
-          <p:cNvPr id="33" name="Shape 31"/>
-          <p:cNvSpPr/>
-          <p:nvPr/>
-        </p:nvSpPr>
-        <p:spPr>
-          <a:xfrm>
-            <a:off x="0" y="4572000"/>
-            <a:ext cx="9144000" cy="0"/>
-          </a:xfrm>
-          <a:prstGeom prst="line">
-            <a:avLst/>
-          </a:prstGeom>
-          <a:noFill/>
-          <a:ln w="3810">
-            <a:solidFill>
-              <a:srgbClr val="C9A84C">
-                <a:alpha val="7000"/>
-              </a:srgbClr>
-            </a:solidFill>
-            <a:prstDash val="solid"/>
-          </a:ln>
-        </p:spPr>
-        <p:txBody>
-          <a:bodyPr/>
-          <a:p/>
-        </p:txBody>
-      </p:sp>
-      <p:sp>
-        <p:nvSpPr>
-          <p:cNvPr id="34" name="Shape 32"/>
-          <p:cNvSpPr/>
-          <p:nvPr/>
-        </p:nvSpPr>
-        <p:spPr>
-          <a:xfrm>
-            <a:off x="0" y="5029200"/>
-            <a:ext cx="9144000" cy="0"/>
-          </a:xfrm>
-          <a:prstGeom prst="line">
-            <a:avLst/>
-          </a:prstGeom>
-          <a:noFill/>
-          <a:ln w="3810">
-            <a:solidFill>
-              <a:srgbClr val="C9A84C">
-                <a:alpha val="7000"/>
-              </a:srgbClr>
-            </a:solidFill>
-            <a:prstDash val="solid"/>
-          </a:ln>
-        </p:spPr>
-        <p:txBody>
-          <a:bodyPr/>
-          <a:p/>
-        </p:txBody>
-      </p:sp>
-      <p:sp>
-        <p:nvSpPr>
-          <p:cNvPr id="35" name="Shape 33"/>
-          <p:cNvSpPr/>
-          <p:nvPr/>
-        </p:nvSpPr>
-        <p:spPr>
-          <a:xfrm>
-            <a:off x="0" y="5486400"/>
-            <a:ext cx="9144000" cy="0"/>
-          </a:xfrm>
-          <a:prstGeom prst="line">
-            <a:avLst/>
-          </a:prstGeom>
-          <a:noFill/>
-          <a:ln w="3810">
-            <a:solidFill>
-              <a:srgbClr val="C9A84C">
-                <a:alpha val="7000"/>
-              </a:srgbClr>
-            </a:solidFill>
-            <a:prstDash val="solid"/>
-          </a:ln>
-        </p:spPr>
-        <p:txBody>
-          <a:bodyPr/>
-          <a:p/>
-        </p:txBody>
-      </p:sp>
-      <p:sp>
-        <p:nvSpPr>
-          <p:cNvPr id="36" name="Shape 34"/>
-          <p:cNvSpPr/>
-          <p:nvPr/>
-        </p:nvSpPr>
-        <p:spPr>
-          <a:xfrm>
-            <a:off x="8503920" y="201168"/>
-            <a:ext cx="365760" cy="365760"/>
-          </a:xfrm>
-          <a:prstGeom prst="ellipse">
+            <a:ext cx="9144000" cy="5143500"/>
+          </a:xfrm>
+          <a:prstGeom prst="rect">
             <a:avLst/>
           </a:prstGeom>
           <a:solidFill>
             <a:srgbClr val="0A0F2E"/>
           </a:solidFill>
-          <a:ln w="19050">
-            <a:solidFill>
-              <a:srgbClr val="C9A84C"/>
-            </a:solidFill>
-            <a:prstDash val="solid"/>
-          </a:ln>
-        </p:spPr>
-        <p:txBody>
-          <a:bodyPr/>
-          <a:p/>
-        </p:txBody>
-      </p:sp>
-      <p:sp>
-        <p:nvSpPr>
-          <p:cNvPr id="37" name="Text 35"/>
-          <p:cNvSpPr/>
-          <p:nvPr/>
-        </p:nvSpPr>
-        <p:spPr>
-          <a:xfrm>
-            <a:off x="8503920" y="201168"/>
-            <a:ext cx="365760" cy="365760"/>
-          </a:xfrm>
-          <a:prstGeom prst="rect">
-            <a:avLst/>
-          </a:prstGeom>
-          <a:noFill/>
-          <a:ln/>
-        </p:spPr>
-        <p:txBody>
-          <a:bodyPr wrap="square" lIns="0" tIns="0" rIns="0" bIns="0" rtlCol="0" anchor="ctr"/>
-          <a:lstStyle/>
-          <a:p>
-            <a:pPr algn="ctr" indent="0" marL="0">
-              <a:buNone/>
-            </a:pPr>
-            <a:r>
-              <a:rPr lang="en-US" sz="900" b="1" dirty="0">
+          <a:ln>
+            <a:noFill/>
+          </a:ln>
+        </p:spPr>
+        <p:style>
+          <a:lnRef idx="1">
+            <a:schemeClr val="accent1"/>
+          </a:lnRef>
+          <a:fillRef idx="3">
+            <a:schemeClr val="accent1"/>
+          </a:fillRef>
+          <a:effectRef idx="2">
+            <a:schemeClr val="accent1"/>
+          </a:effectRef>
+          <a:fontRef idx="minor">
+            <a:schemeClr val="lt1"/>
+          </a:fontRef>
+        </p:style>
+        <p:txBody>
+          <a:bodyPr rtlCol="0" anchor="ctr"/>
+          <a:lstStyle/>
+          <a:p>
+            <a:pPr algn="ctr"/>
+          </a:p>
+        </p:txBody>
+      </p:sp>
+      <p:sp>
+        <p:nvSpPr>
+          <p:cNvPr id="3" name="TextBox 2"/>
+          <p:cNvSpPr txBox="1"/>
+          <p:nvPr/>
+        </p:nvSpPr>
+        <p:spPr>
+          <a:xfrm>
+            <a:off x="347472" y="274320"/>
+            <a:ext cx="502920" cy="329184"/>
+          </a:xfrm>
+          <a:prstGeom prst="rect">
+            <a:avLst/>
+          </a:prstGeom>
+          <a:noFill/>
+        </p:spPr>
+        <p:txBody>
+          <a:bodyPr wrap="square">
+            <a:spAutoFit/>
+          </a:bodyPr>
+          <a:lstStyle/>
+          <a:p>
+            <a:pPr algn="l"/>
+            <a:r>
+              <a:rPr sz="1100" b="1" i="0">
                 <a:solidFill>
                   <a:srgbClr val="C9A84C"/>
                 </a:solidFill>
-                <a:latin typeface="Cambria" pitchFamily="34" charset="0"/>
-                <a:ea typeface="Cambria" pitchFamily="34" charset="-122"/>
-                <a:cs typeface="Cambria" pitchFamily="34" charset="-120"/>
+                <a:latin typeface="Georgia"/>
               </a:rPr>
               <a:t>VM</a:t>
             </a:r>
-            <a:endParaRPr lang="en-US" sz="900" dirty="0"/>
-          </a:p>
-        </p:txBody>
-      </p:sp>
-      <p:sp>
-        <p:nvSpPr>
-          <p:cNvPr id="38" name="Text 36"/>
-          <p:cNvSpPr/>
-          <p:nvPr/>
-        </p:nvSpPr>
-        <p:spPr>
-          <a:xfrm>
-            <a:off x="7178040" y="228600"/>
-            <a:ext cx="1234440" cy="164592"/>
-          </a:xfrm>
-          <a:prstGeom prst="rect">
-            <a:avLst/>
-          </a:prstGeom>
-          <a:noFill/>
-          <a:ln/>
-        </p:spPr>
-        <p:txBody>
-          <a:bodyPr wrap="square" lIns="0" tIns="0" rIns="0" bIns="0" rtlCol="0" anchor="ctr"/>
-          <a:lstStyle/>
-          <a:p>
-            <a:pPr algn="r" indent="0" marL="0">
-              <a:buNone/>
-            </a:pPr>
-            <a:r>
-              <a:rPr lang="en-US" sz="700" b="1" dirty="0">
-                <a:solidFill>
-                  <a:srgbClr val="F8F7F4"/>
-                </a:solidFill>
-                <a:latin typeface="Calibri" pitchFamily="34" charset="0"/>
-                <a:ea typeface="Calibri" pitchFamily="34" charset="-122"/>
-                <a:cs typeface="Calibri" pitchFamily="34" charset="-120"/>
-              </a:rPr>
-              <a:t>VAUGHNMARTIN</a:t>
-            </a:r>
-            <a:endParaRPr lang="en-US" sz="700" dirty="0"/>
-          </a:p>
-        </p:txBody>
-      </p:sp>
-      <p:sp>
-        <p:nvSpPr>
-          <p:cNvPr id="39" name="Shape 37"/>
-          <p:cNvSpPr/>
-          <p:nvPr/>
-        </p:nvSpPr>
-        <p:spPr>
-          <a:xfrm>
-            <a:off x="411480" y="201168"/>
-            <a:ext cx="4937760" cy="2377440"/>
-          </a:xfrm>
-          <a:prstGeom prst="roundRect">
-            <a:avLst>
-              <a:gd name="adj" fmla="val 3846"/>
-            </a:avLst>
+          </a:p>
+        </p:txBody>
+      </p:sp>
+      <p:sp>
+        <p:nvSpPr>
+          <p:cNvPr id="4" name="TextBox 3"/>
+          <p:cNvSpPr txBox="1"/>
+          <p:nvPr/>
+        </p:nvSpPr>
+        <p:spPr>
+          <a:xfrm>
+            <a:off x="1005840" y="292608"/>
+            <a:ext cx="3657600" cy="256032"/>
+          </a:xfrm>
+          <a:prstGeom prst="rect">
+            <a:avLst/>
+          </a:prstGeom>
+          <a:noFill/>
+        </p:spPr>
+        <p:txBody>
+          <a:bodyPr wrap="square">
+            <a:spAutoFit/>
+          </a:bodyPr>
+          <a:lstStyle/>
+          <a:p>
+            <a:pPr algn="l"/>
+            <a:r>
+              <a:rPr sz="800" b="1" i="0">
+                <a:solidFill>
+                  <a:srgbClr val="C9A84C"/>
+                </a:solidFill>
+                <a:latin typeface="Barlow"/>
+              </a:rPr>
+              <a:t>THIRD-PARTY VALIDATION</a:t>
+            </a:r>
+          </a:p>
+        </p:txBody>
+      </p:sp>
+      <p:sp>
+        <p:nvSpPr>
+          <p:cNvPr id="5" name="Rectangle 4"/>
+          <p:cNvSpPr/>
+          <p:nvPr/>
+        </p:nvSpPr>
+        <p:spPr>
+          <a:xfrm>
+            <a:off x="347472" y="694944"/>
+            <a:ext cx="8503920" cy="16459"/>
+          </a:xfrm>
+          <a:prstGeom prst="rect">
+            <a:avLst/>
           </a:prstGeom>
           <a:solidFill>
-            <a:srgbClr val="0A0C1A"/>
+            <a:srgbClr val="C9A84C"/>
           </a:solidFill>
-          <a:ln w="12700">
-            <a:solidFill>
-              <a:srgbClr val="C9A84C">
-                <a:alpha val="72000"/>
-              </a:srgbClr>
-            </a:solidFill>
-            <a:prstDash val="solid"/>
-          </a:ln>
-        </p:spPr>
-        <p:txBody>
-          <a:bodyPr/>
-          <a:p/>
-        </p:txBody>
-      </p:sp>
-      <p:sp>
-        <p:nvSpPr>
-          <p:cNvPr id="40" name="Text 38"/>
-          <p:cNvSpPr/>
-          <p:nvPr/>
-        </p:nvSpPr>
-        <p:spPr>
-          <a:xfrm>
-            <a:off x="548640" y="228600"/>
-            <a:ext cx="822960" cy="822960"/>
-          </a:xfrm>
-          <a:prstGeom prst="rect">
-            <a:avLst/>
-          </a:prstGeom>
-          <a:noFill/>
-          <a:ln/>
-        </p:spPr>
-        <p:txBody>
-          <a:bodyPr wrap="square" lIns="0" tIns="0" rIns="0" bIns="0" rtlCol="0" anchor="ctr"/>
-          <a:lstStyle/>
-          <a:p>
-            <a:pPr indent="0" marL="0">
-              <a:buNone/>
-            </a:pPr>
-            <a:r>
-              <a:rPr lang="en-US" sz="7000" dirty="0">
-                <a:solidFill>
-                  <a:srgbClr val="C9A84C">
-                    <a:alpha val="80000"/>
-                  </a:srgbClr>
-                </a:solidFill>
-                <a:latin typeface="Cambria" pitchFamily="34" charset="0"/>
-                <a:ea typeface="Cambria" pitchFamily="34" charset="-122"/>
-                <a:cs typeface="Cambria" pitchFamily="34" charset="-120"/>
+          <a:ln>
+            <a:noFill/>
+          </a:ln>
+        </p:spPr>
+        <p:style>
+          <a:lnRef idx="1">
+            <a:schemeClr val="accent1"/>
+          </a:lnRef>
+          <a:fillRef idx="3">
+            <a:schemeClr val="accent1"/>
+          </a:fillRef>
+          <a:effectRef idx="2">
+            <a:schemeClr val="accent1"/>
+          </a:effectRef>
+          <a:fontRef idx="minor">
+            <a:schemeClr val="lt1"/>
+          </a:fontRef>
+        </p:style>
+        <p:txBody>
+          <a:bodyPr rtlCol="0" anchor="ctr"/>
+          <a:lstStyle/>
+          <a:p>
+            <a:pPr algn="ctr"/>
+          </a:p>
+        </p:txBody>
+      </p:sp>
+      <p:sp>
+        <p:nvSpPr>
+          <p:cNvPr id="6" name="TextBox 5"/>
+          <p:cNvSpPr txBox="1"/>
+          <p:nvPr/>
+        </p:nvSpPr>
+        <p:spPr>
+          <a:xfrm>
+            <a:off x="502920" y="804672"/>
+            <a:ext cx="914400" cy="1097280"/>
+          </a:xfrm>
+          <a:prstGeom prst="rect">
+            <a:avLst/>
+          </a:prstGeom>
+          <a:noFill/>
+        </p:spPr>
+        <p:txBody>
+          <a:bodyPr wrap="square">
+            <a:spAutoFit/>
+          </a:bodyPr>
+          <a:lstStyle/>
+          <a:p>
+            <a:pPr algn="l"/>
+            <a:r>
+              <a:rPr sz="12000" b="0" i="0">
+                <a:solidFill>
+                  <a:srgbClr val="C9A84C"/>
+                </a:solidFill>
+                <a:latin typeface="Georgia"/>
               </a:rPr>
               <a:t>“</a:t>
             </a:r>
-            <a:endParaRPr lang="en-US" sz="7000" dirty="0"/>
-          </a:p>
-        </p:txBody>
-      </p:sp>
-      <p:sp>
-        <p:nvSpPr>
-          <p:cNvPr id="41" name="Text 39"/>
-          <p:cNvSpPr/>
-          <p:nvPr/>
-        </p:nvSpPr>
-        <p:spPr>
-          <a:xfrm>
-            <a:off x="594360" y="621792"/>
-            <a:ext cx="4572000" cy="1051560"/>
-          </a:xfrm>
-          <a:prstGeom prst="rect">
-            <a:avLst/>
-          </a:prstGeom>
-          <a:noFill/>
-          <a:ln/>
-        </p:spPr>
-        <p:txBody>
-          <a:bodyPr wrap="square" lIns="0" tIns="0" rIns="0" bIns="0" rtlCol="0" anchor="ctr"/>
-          <a:lstStyle/>
-          <a:p>
-            <a:pPr indent="0" marL="0">
-              <a:buNone/>
-            </a:pPr>
-            <a:r>
-              <a:rPr lang="en-US" sz="1600" b="1" i="1" dirty="0">
-                <a:solidFill>
-                  <a:srgbClr val="F8F7F4">
-                    <a:alpha val="92000"/>
-                  </a:srgbClr>
-                </a:solidFill>
-                <a:latin typeface="Cambria" pitchFamily="34" charset="0"/>
-                <a:ea typeface="Cambria" pitchFamily="34" charset="-122"/>
-                <a:cs typeface="Cambria" pitchFamily="34" charset="-120"/>
+          </a:p>
+        </p:txBody>
+      </p:sp>
+      <p:sp>
+        <p:nvSpPr>
+          <p:cNvPr id="7" name="TextBox 6"/>
+          <p:cNvSpPr txBox="1"/>
+          <p:nvPr/>
+        </p:nvSpPr>
+        <p:spPr>
+          <a:xfrm>
+            <a:off x="822960" y="1188720"/>
+            <a:ext cx="7543800" cy="1645920"/>
+          </a:xfrm>
+          <a:prstGeom prst="rect">
+            <a:avLst/>
+          </a:prstGeom>
+          <a:noFill/>
+        </p:spPr>
+        <p:txBody>
+          <a:bodyPr wrap="square">
+            <a:spAutoFit/>
+          </a:bodyPr>
+          <a:lstStyle/>
+          <a:p>
+            <a:pPr algn="l"/>
+            <a:r>
+              <a:rPr sz="2800" b="0" i="1">
+                <a:solidFill>
+                  <a:srgbClr val="FFFFFF"/>
+                </a:solidFill>
+                <a:latin typeface="Georgia"/>
               </a:rPr>
               <a:t>Martin is building the architecture that makes clarity possible before pressure arrives.</a:t>
             </a:r>
-            <a:endParaRPr lang="en-US" sz="1600" dirty="0"/>
-          </a:p>
-        </p:txBody>
-      </p:sp>
-      <p:sp>
-        <p:nvSpPr>
-          <p:cNvPr id="42" name="Shape 40"/>
-          <p:cNvSpPr/>
-          <p:nvPr/>
-        </p:nvSpPr>
-        <p:spPr>
-          <a:xfrm>
-            <a:off x="594360" y="1755648"/>
-            <a:ext cx="1645920" cy="0"/>
-          </a:xfrm>
-          <a:prstGeom prst="line">
-            <a:avLst/>
-          </a:prstGeom>
-          <a:noFill/>
-          <a:ln w="10160">
-            <a:solidFill>
-              <a:srgbClr val="C9A84C">
-                <a:alpha val="60000"/>
-              </a:srgbClr>
-            </a:solidFill>
-            <a:prstDash val="solid"/>
-          </a:ln>
-        </p:spPr>
-        <p:txBody>
-          <a:bodyPr/>
-          <a:p/>
-        </p:txBody>
-      </p:sp>
-      <p:sp>
-        <p:nvSpPr>
-          <p:cNvPr id="43" name="Text 41"/>
-          <p:cNvSpPr/>
-          <p:nvPr/>
-        </p:nvSpPr>
-        <p:spPr>
-          <a:xfrm>
-            <a:off x="594360" y="1847088"/>
-            <a:ext cx="4114800" cy="274320"/>
-          </a:xfrm>
-          <a:prstGeom prst="rect">
-            <a:avLst/>
-          </a:prstGeom>
-          <a:noFill/>
-          <a:ln/>
-        </p:spPr>
-        <p:txBody>
-          <a:bodyPr wrap="square" lIns="0" tIns="0" rIns="0" bIns="0" rtlCol="0" anchor="ctr"/>
-          <a:lstStyle/>
-          <a:p>
-            <a:pPr indent="0" marL="0">
-              <a:buNone/>
-            </a:pPr>
-            <a:r>
-              <a:rPr lang="en-US" sz="1400" b="1" dirty="0">
+          </a:p>
+        </p:txBody>
+      </p:sp>
+      <p:sp>
+        <p:nvSpPr>
+          <p:cNvPr id="8" name="Rectangle 7"/>
+          <p:cNvSpPr/>
+          <p:nvPr/>
+        </p:nvSpPr>
+        <p:spPr>
+          <a:xfrm>
+            <a:off x="822960" y="2926080"/>
+            <a:ext cx="3474720" cy="16459"/>
+          </a:xfrm>
+          <a:prstGeom prst="rect">
+            <a:avLst/>
+          </a:prstGeom>
+          <a:solidFill>
+            <a:srgbClr val="C9A84C"/>
+          </a:solidFill>
+          <a:ln>
+            <a:noFill/>
+          </a:ln>
+        </p:spPr>
+        <p:style>
+          <a:lnRef idx="1">
+            <a:schemeClr val="accent1"/>
+          </a:lnRef>
+          <a:fillRef idx="3">
+            <a:schemeClr val="accent1"/>
+          </a:fillRef>
+          <a:effectRef idx="2">
+            <a:schemeClr val="accent1"/>
+          </a:effectRef>
+          <a:fontRef idx="minor">
+            <a:schemeClr val="lt1"/>
+          </a:fontRef>
+        </p:style>
+        <p:txBody>
+          <a:bodyPr rtlCol="0" anchor="ctr"/>
+          <a:lstStyle/>
+          <a:p>
+            <a:pPr algn="ctr"/>
+          </a:p>
+        </p:txBody>
+      </p:sp>
+      <p:sp>
+        <p:nvSpPr>
+          <p:cNvPr id="9" name="TextBox 8"/>
+          <p:cNvSpPr txBox="1"/>
+          <p:nvPr/>
+        </p:nvSpPr>
+        <p:spPr>
+          <a:xfrm>
+            <a:off x="822960" y="3035808"/>
+            <a:ext cx="4572000" cy="347472"/>
+          </a:xfrm>
+          <a:prstGeom prst="rect">
+            <a:avLst/>
+          </a:prstGeom>
+          <a:noFill/>
+        </p:spPr>
+        <p:txBody>
+          <a:bodyPr wrap="square">
+            <a:spAutoFit/>
+          </a:bodyPr>
+          <a:lstStyle/>
+          <a:p>
+            <a:pPr algn="l"/>
+            <a:r>
+              <a:rPr sz="1300" b="1" i="0">
                 <a:solidFill>
                   <a:srgbClr val="C9A84C"/>
                 </a:solidFill>
-                <a:latin typeface="Cambria" pitchFamily="34" charset="0"/>
-                <a:ea typeface="Cambria" pitchFamily="34" charset="-122"/>
-                <a:cs typeface="Cambria" pitchFamily="34" charset="-120"/>
-              </a:rPr>
-              <a:t>Dr. Kerry Huang</a:t>
-            </a:r>
-            <a:endParaRPr lang="en-US" sz="1400" dirty="0"/>
-          </a:p>
-        </p:txBody>
-      </p:sp>
-      <p:sp>
-        <p:nvSpPr>
-          <p:cNvPr id="44" name="Text 42"/>
-          <p:cNvSpPr/>
-          <p:nvPr/>
-        </p:nvSpPr>
-        <p:spPr>
-          <a:xfrm>
-            <a:off x="594360" y="2157984"/>
-            <a:ext cx="4572000" cy="219456"/>
-          </a:xfrm>
-          <a:prstGeom prst="rect">
-            <a:avLst/>
-          </a:prstGeom>
-          <a:noFill/>
-          <a:ln/>
-        </p:spPr>
-        <p:txBody>
-          <a:bodyPr wrap="square" lIns="0" tIns="0" rIns="0" bIns="0" rtlCol="0" anchor="ctr"/>
-          <a:lstStyle/>
-          <a:p>
-            <a:pPr indent="0" marL="0">
-              <a:buNone/>
-            </a:pPr>
-            <a:r>
-              <a:rPr lang="en-US" sz="950" dirty="0">
-                <a:solidFill>
-                  <a:srgbClr val="F8F7F4">
-                    <a:alpha val="62000"/>
-                  </a:srgbClr>
-                </a:solidFill>
-                <a:latin typeface="Calibri" pitchFamily="34" charset="0"/>
-                <a:ea typeface="Calibri" pitchFamily="34" charset="-122"/>
-                <a:cs typeface="Calibri" pitchFamily="34" charset="-120"/>
-              </a:rPr>
-              <a:t>Fortune 50 AVP  ·  ESI Top 1% Researcher  ·  Forbes Business Council  ·  408-firm study</a:t>
-            </a:r>
-            <a:endParaRPr lang="en-US" sz="950" dirty="0"/>
-          </a:p>
-        </p:txBody>
-      </p:sp>
-      <p:sp>
-        <p:nvSpPr>
-          <p:cNvPr id="45" name="Text 43"/>
-          <p:cNvSpPr/>
-          <p:nvPr/>
-        </p:nvSpPr>
-        <p:spPr>
-          <a:xfrm>
-            <a:off x="594360" y="2395728"/>
-            <a:ext cx="4572000" cy="182880"/>
-          </a:xfrm>
-          <a:prstGeom prst="rect">
-            <a:avLst/>
-          </a:prstGeom>
-          <a:noFill/>
-          <a:ln/>
-        </p:spPr>
-        <p:txBody>
-          <a:bodyPr wrap="square" lIns="0" tIns="0" rIns="0" bIns="0" rtlCol="0" anchor="ctr"/>
-          <a:lstStyle/>
-          <a:p>
-            <a:pPr indent="0" marL="0">
-              <a:buNone/>
-            </a:pPr>
-            <a:r>
-              <a:rPr lang="en-US" sz="900" i="1" dirty="0">
-                <a:solidFill>
-                  <a:srgbClr val="C9A84C">
-                    <a:alpha val="52000"/>
-                  </a:srgbClr>
-                </a:solidFill>
-                <a:latin typeface="Calibri" pitchFamily="34" charset="0"/>
-                <a:ea typeface="Calibri" pitchFamily="34" charset="-122"/>
-                <a:cs typeface="Calibri" pitchFamily="34" charset="-120"/>
-              </a:rPr>
-              <a:t>Public repost · April 2026 · After 4 weeks of direct platform review</a:t>
-            </a:r>
-            <a:endParaRPr lang="en-US" sz="900" dirty="0"/>
-          </a:p>
-        </p:txBody>
-      </p:sp>
-      <p:sp>
-        <p:nvSpPr>
-          <p:cNvPr id="46" name="Shape 44"/>
-          <p:cNvSpPr/>
-          <p:nvPr/>
-        </p:nvSpPr>
-        <p:spPr>
-          <a:xfrm>
-            <a:off x="5532120" y="201168"/>
-            <a:ext cx="2880360" cy="2377440"/>
-          </a:xfrm>
-          <a:prstGeom prst="roundRect">
-            <a:avLst>
-              <a:gd name="adj" fmla="val 3846"/>
-            </a:avLst>
+                <a:latin typeface="Barlow"/>
+              </a:rPr>
+              <a:t>DR. KERRY HUANG</a:t>
+            </a:r>
+          </a:p>
+        </p:txBody>
+      </p:sp>
+      <p:sp>
+        <p:nvSpPr>
+          <p:cNvPr id="10" name="TextBox 9"/>
+          <p:cNvSpPr txBox="1"/>
+          <p:nvPr/>
+        </p:nvSpPr>
+        <p:spPr>
+          <a:xfrm>
+            <a:off x="822960" y="3401568"/>
+            <a:ext cx="6400800" cy="274320"/>
+          </a:xfrm>
+          <a:prstGeom prst="rect">
+            <a:avLst/>
+          </a:prstGeom>
+          <a:noFill/>
+        </p:spPr>
+        <p:txBody>
+          <a:bodyPr wrap="square">
+            <a:spAutoFit/>
+          </a:bodyPr>
+          <a:lstStyle/>
+          <a:p>
+            <a:pPr algn="l"/>
+            <a:r>
+              <a:rPr sz="1100" b="0" i="0">
+                <a:solidFill>
+                  <a:srgbClr val="CCCCCC"/>
+                </a:solidFill>
+                <a:latin typeface="Barlow"/>
+              </a:rPr>
+              <a:t>Fortune 50 AVP  ·  ESI Top 1% Researcher  ·  Forbes Business Council</a:t>
+            </a:r>
+          </a:p>
+        </p:txBody>
+      </p:sp>
+      <p:sp>
+        <p:nvSpPr>
+          <p:cNvPr id="11" name="TextBox 10"/>
+          <p:cNvSpPr txBox="1"/>
+          <p:nvPr/>
+        </p:nvSpPr>
+        <p:spPr>
+          <a:xfrm>
+            <a:off x="822960" y="3694176"/>
+            <a:ext cx="6400800" cy="256032"/>
+          </a:xfrm>
+          <a:prstGeom prst="rect">
+            <a:avLst/>
+          </a:prstGeom>
+          <a:noFill/>
+        </p:spPr>
+        <p:txBody>
+          <a:bodyPr wrap="square">
+            <a:spAutoFit/>
+          </a:bodyPr>
+          <a:lstStyle/>
+          <a:p>
+            <a:pPr algn="l"/>
+            <a:r>
+              <a:rPr sz="1000" b="0" i="1">
+                <a:solidFill>
+                  <a:srgbClr val="777788"/>
+                </a:solidFill>
+                <a:latin typeface="Barlow"/>
+              </a:rPr>
+              <a:t>408-firm study basis  ·  4 weeks of direct platform review  ·  Public repost · April 2026</a:t>
+            </a:r>
+          </a:p>
+        </p:txBody>
+      </p:sp>
+      <p:sp>
+        <p:nvSpPr>
+          <p:cNvPr id="12" name="Rectangle 11"/>
+          <p:cNvSpPr/>
+          <p:nvPr/>
+        </p:nvSpPr>
+        <p:spPr>
+          <a:xfrm>
+            <a:off x="0" y="4114800"/>
+            <a:ext cx="9144000" cy="1028700"/>
+          </a:xfrm>
+          <a:prstGeom prst="rect">
+            <a:avLst/>
           </a:prstGeom>
           <a:solidFill>
-            <a:srgbClr val="0A0C1A"/>
+            <a:srgbClr val="0D1438"/>
           </a:solidFill>
-          <a:ln w="12700">
-            <a:solidFill>
-              <a:srgbClr val="2B8A6E">
-                <a:alpha val="72000"/>
-              </a:srgbClr>
-            </a:solidFill>
-            <a:prstDash val="solid"/>
-          </a:ln>
-        </p:spPr>
-        <p:txBody>
-          <a:bodyPr/>
-          <a:p/>
-        </p:txBody>
-      </p:sp>
-      <p:sp>
-        <p:nvSpPr>
-          <p:cNvPr id="47" name="Text 45"/>
-          <p:cNvSpPr/>
-          <p:nvPr/>
-        </p:nvSpPr>
-        <p:spPr>
-          <a:xfrm>
-            <a:off x="5532120" y="292608"/>
-            <a:ext cx="2880360" cy="237744"/>
-          </a:xfrm>
-          <a:prstGeom prst="rect">
-            <a:avLst/>
-          </a:prstGeom>
-          <a:noFill/>
-          <a:ln/>
-        </p:spPr>
-        <p:txBody>
-          <a:bodyPr wrap="square" lIns="0" tIns="0" rIns="0" bIns="0" rtlCol="0" anchor="ctr"/>
-          <a:lstStyle/>
-          <a:p>
-            <a:pPr indent="0" marL="0">
-              <a:buNone/>
-            </a:pPr>
-            <a:r>
-              <a:rPr lang="en-US" sz="800" b="1" dirty="0">
-                <a:solidFill>
-                  <a:srgbClr val="2B8A6E">
-                    <a:alpha val="80000"/>
-                  </a:srgbClr>
-                </a:solidFill>
-                <a:latin typeface="Calibri" pitchFamily="34" charset="0"/>
-                <a:ea typeface="Calibri" pitchFamily="34" charset="-122"/>
-                <a:cs typeface="Calibri" pitchFamily="34" charset="-120"/>
-              </a:rPr>
-              <a:t>CUSTOMER ECONOMICS</a:t>
-            </a:r>
-            <a:endParaRPr lang="en-US" sz="800" dirty="0"/>
-          </a:p>
-        </p:txBody>
-      </p:sp>
-      <p:sp>
-        <p:nvSpPr>
-          <p:cNvPr id="48" name="Shape 46"/>
-          <p:cNvSpPr/>
-          <p:nvPr/>
-        </p:nvSpPr>
-        <p:spPr>
-          <a:xfrm>
-            <a:off x="5532120" y="292608"/>
-            <a:ext cx="3246120" cy="0"/>
-          </a:xfrm>
-          <a:prstGeom prst="line">
-            <a:avLst/>
-          </a:prstGeom>
-          <a:noFill/>
-          <a:ln w="12700">
-            <a:solidFill>
-              <a:srgbClr val="2B8A6E">
-                <a:alpha val="0"/>
-              </a:srgbClr>
-            </a:solidFill>
-            <a:prstDash val="solid"/>
-          </a:ln>
-        </p:spPr>
-        <p:txBody>
-          <a:bodyPr/>
-          <a:p/>
-        </p:txBody>
-      </p:sp>
-      <p:sp>
-        <p:nvSpPr>
-          <p:cNvPr id="49" name="Text 47"/>
-          <p:cNvSpPr/>
-          <p:nvPr/>
-        </p:nvSpPr>
-        <p:spPr>
-          <a:xfrm>
-            <a:off x="5623560" y="530352"/>
-            <a:ext cx="1920240" cy="256032"/>
-          </a:xfrm>
-          <a:prstGeom prst="rect">
-            <a:avLst/>
-          </a:prstGeom>
-          <a:noFill/>
-          <a:ln/>
-        </p:spPr>
-        <p:txBody>
-          <a:bodyPr wrap="square" lIns="0" tIns="0" rIns="0" bIns="0" rtlCol="0" anchor="ctr"/>
-          <a:lstStyle/>
-          <a:p>
-            <a:pPr indent="0" marL="0">
-              <a:buNone/>
-            </a:pPr>
-            <a:r>
-              <a:rPr lang="en-US" sz="1000" dirty="0">
-                <a:solidFill>
-                  <a:srgbClr val="F8F7F4">
-                    <a:alpha val="72000"/>
-                  </a:srgbClr>
-                </a:solidFill>
-                <a:latin typeface="Calibri" pitchFamily="34" charset="0"/>
-                <a:ea typeface="Calibri" pitchFamily="34" charset="-122"/>
-                <a:cs typeface="Calibri" pitchFamily="34" charset="-120"/>
-              </a:rPr>
-              <a:t>Founding Partner entry</a:t>
-            </a:r>
-            <a:endParaRPr lang="en-US" sz="1000" dirty="0"/>
-          </a:p>
-        </p:txBody>
-      </p:sp>
-      <p:sp>
-        <p:nvSpPr>
-          <p:cNvPr id="50" name="Text 48"/>
-          <p:cNvSpPr/>
-          <p:nvPr/>
-        </p:nvSpPr>
-        <p:spPr>
-          <a:xfrm>
-            <a:off x="7406640" y="530352"/>
-            <a:ext cx="1234440" cy="256032"/>
-          </a:xfrm>
-          <a:prstGeom prst="rect">
-            <a:avLst/>
-          </a:prstGeom>
-          <a:noFill/>
-          <a:ln/>
-        </p:spPr>
-        <p:txBody>
-          <a:bodyPr wrap="square" lIns="0" tIns="0" rIns="0" bIns="0" rtlCol="0" anchor="ctr"/>
-          <a:lstStyle/>
-          <a:p>
-            <a:pPr algn="r" indent="0" marL="0">
-              <a:buNone/>
-            </a:pPr>
-            <a:r>
-              <a:rPr lang="en-US" sz="1400" b="1" dirty="0">
-                <a:solidFill>
-                  <a:srgbClr val="C9A84C"/>
-                </a:solidFill>
-                <a:latin typeface="Cambria" pitchFamily="34" charset="0"/>
-                <a:ea typeface="Cambria" pitchFamily="34" charset="-122"/>
-                <a:cs typeface="Cambria" pitchFamily="34" charset="-120"/>
-              </a:rPr>
-              <a:t>$75K</a:t>
-            </a:r>
-            <a:endParaRPr lang="en-US" sz="1400" dirty="0"/>
-          </a:p>
-        </p:txBody>
-      </p:sp>
-      <p:sp>
-        <p:nvSpPr>
-          <p:cNvPr id="51" name="Text 49"/>
-          <p:cNvSpPr/>
-          <p:nvPr/>
-        </p:nvSpPr>
-        <p:spPr>
-          <a:xfrm>
-            <a:off x="5623560" y="804672"/>
-            <a:ext cx="3017520" cy="182880"/>
-          </a:xfrm>
-          <a:prstGeom prst="rect">
-            <a:avLst/>
-          </a:prstGeom>
-          <a:noFill/>
-          <a:ln/>
-        </p:spPr>
-        <p:txBody>
-          <a:bodyPr wrap="square" lIns="0" tIns="0" rIns="0" bIns="0" rtlCol="0" anchor="ctr"/>
-          <a:lstStyle/>
-          <a:p>
-            <a:pPr indent="0" marL="0">
-              <a:buNone/>
-            </a:pPr>
-            <a:r>
-              <a:rPr lang="en-US" sz="850" dirty="0">
-                <a:solidFill>
-                  <a:srgbClr val="C9A84C">
-                    <a:alpha val="65000"/>
-                  </a:srgbClr>
-                </a:solidFill>
-                <a:latin typeface="Calibri" pitchFamily="34" charset="0"/>
-                <a:ea typeface="Calibri" pitchFamily="34" charset="-122"/>
-                <a:cs typeface="Calibri" pitchFamily="34" charset="-120"/>
-              </a:rPr>
-              <a:t>90-day  ·  100% credited to Year 1</a:t>
-            </a:r>
-            <a:endParaRPr lang="en-US" sz="850" dirty="0"/>
-          </a:p>
-        </p:txBody>
-      </p:sp>
-      <p:sp>
-        <p:nvSpPr>
-          <p:cNvPr id="52" name="Shape 50"/>
-          <p:cNvSpPr/>
-          <p:nvPr/>
-        </p:nvSpPr>
-        <p:spPr>
-          <a:xfrm>
-            <a:off x="5650992" y="1042416"/>
-            <a:ext cx="2651760" cy="0"/>
-          </a:xfrm>
-          <a:prstGeom prst="line">
-            <a:avLst/>
-          </a:prstGeom>
-          <a:noFill/>
-          <a:ln w="6350">
-            <a:solidFill>
-              <a:srgbClr val="2B8A6E">
-                <a:alpha val="45000"/>
-              </a:srgbClr>
-            </a:solidFill>
-            <a:prstDash val="solid"/>
-          </a:ln>
-        </p:spPr>
-        <p:txBody>
-          <a:bodyPr/>
-          <a:p/>
-        </p:txBody>
-      </p:sp>
-      <p:sp>
-        <p:nvSpPr>
-          <p:cNvPr id="53" name="Text 51"/>
-          <p:cNvSpPr/>
-          <p:nvPr/>
-        </p:nvSpPr>
-        <p:spPr>
-          <a:xfrm>
-            <a:off x="5623560" y="1078992"/>
-            <a:ext cx="3017520" cy="182880"/>
-          </a:xfrm>
-          <a:prstGeom prst="rect">
-            <a:avLst/>
-          </a:prstGeom>
-          <a:noFill/>
-          <a:ln/>
-        </p:spPr>
-        <p:txBody>
-          <a:bodyPr wrap="square" lIns="0" tIns="0" rIns="0" bIns="0" rtlCol="0" anchor="ctr"/>
-          <a:lstStyle/>
-          <a:p>
-            <a:pPr indent="0" marL="0">
-              <a:buNone/>
-            </a:pPr>
-            <a:r>
-              <a:rPr lang="en-US" sz="700" b="1" dirty="0">
-                <a:solidFill>
-                  <a:srgbClr val="2B8A6E">
-                    <a:alpha val="72000"/>
-                  </a:srgbClr>
-                </a:solidFill>
-                <a:latin typeface="Calibri" pitchFamily="34" charset="0"/>
-                <a:ea typeface="Calibri" pitchFamily="34" charset="-122"/>
-                <a:cs typeface="Calibri" pitchFamily="34" charset="-120"/>
-              </a:rPr>
-              <a:t>CHOOSE YOUR TIER</a:t>
-            </a:r>
-            <a:endParaRPr lang="en-US" sz="700" dirty="0"/>
-          </a:p>
-        </p:txBody>
-      </p:sp>
-      <p:sp>
-        <p:nvSpPr>
-          <p:cNvPr id="54" name="Text 52"/>
-          <p:cNvSpPr/>
-          <p:nvPr/>
-        </p:nvSpPr>
-        <p:spPr>
-          <a:xfrm>
-            <a:off x="5623560" y="1298448"/>
-            <a:ext cx="1280160" cy="274320"/>
-          </a:xfrm>
-          <a:prstGeom prst="rect">
-            <a:avLst/>
-          </a:prstGeom>
-          <a:noFill/>
-          <a:ln/>
-        </p:spPr>
-        <p:txBody>
-          <a:bodyPr wrap="square" lIns="0" tIns="0" rIns="0" bIns="0" rtlCol="0" anchor="ctr"/>
-          <a:lstStyle/>
-          <a:p>
-            <a:pPr indent="0" marL="0">
-              <a:buNone/>
-            </a:pPr>
-            <a:r>
-              <a:rPr lang="en-US" sz="1100" b="1" dirty="0">
-                <a:solidFill>
-                  <a:srgbClr val="F8F7F4">
-                    <a:alpha val="86000"/>
-                  </a:srgbClr>
-                </a:solidFill>
-                <a:latin typeface="Calibri" pitchFamily="34" charset="0"/>
-                <a:ea typeface="Calibri" pitchFamily="34" charset="-122"/>
-                <a:cs typeface="Calibri" pitchFamily="34" charset="-120"/>
-              </a:rPr>
-              <a:t>Core</a:t>
-            </a:r>
-            <a:endParaRPr lang="en-US" sz="1100" dirty="0"/>
-          </a:p>
-        </p:txBody>
-      </p:sp>
-      <p:sp>
-        <p:nvSpPr>
-          <p:cNvPr id="55" name="Text 53"/>
-          <p:cNvSpPr/>
-          <p:nvPr/>
-        </p:nvSpPr>
-        <p:spPr>
-          <a:xfrm>
-            <a:off x="7178040" y="1298448"/>
-            <a:ext cx="1143000" cy="274320"/>
-          </a:xfrm>
-          <a:prstGeom prst="rect">
-            <a:avLst/>
-          </a:prstGeom>
-          <a:noFill/>
-          <a:ln/>
-        </p:spPr>
-        <p:txBody>
-          <a:bodyPr wrap="square" lIns="0" tIns="0" rIns="0" bIns="0" rtlCol="0" anchor="ctr"/>
-          <a:lstStyle/>
-          <a:p>
-            <a:pPr algn="r" indent="0" marL="0">
-              <a:buNone/>
-            </a:pPr>
-            <a:r>
-              <a:rPr lang="en-US" sz="1100" b="1" dirty="0">
-                <a:solidFill>
-                  <a:srgbClr val="F8F7F4">
-                    <a:alpha val="82000"/>
-                  </a:srgbClr>
-                </a:solidFill>
-                <a:latin typeface="Cambria" pitchFamily="34" charset="0"/>
-                <a:ea typeface="Cambria" pitchFamily="34" charset="-122"/>
-                <a:cs typeface="Cambria" pitchFamily="34" charset="-120"/>
-              </a:rPr>
-              <a:t>$150K/yr</a:t>
-            </a:r>
-            <a:endParaRPr lang="en-US" sz="1100" dirty="0"/>
-          </a:p>
-        </p:txBody>
-      </p:sp>
-      <p:sp>
-        <p:nvSpPr>
-          <p:cNvPr id="56" name="Text 54"/>
-          <p:cNvSpPr/>
-          <p:nvPr/>
-        </p:nvSpPr>
-        <p:spPr>
-          <a:xfrm>
-            <a:off x="5623560" y="1609344"/>
-            <a:ext cx="1280160" cy="274320"/>
-          </a:xfrm>
-          <a:prstGeom prst="rect">
-            <a:avLst/>
-          </a:prstGeom>
-          <a:noFill/>
-          <a:ln/>
-        </p:spPr>
-        <p:txBody>
-          <a:bodyPr wrap="square" lIns="0" tIns="0" rIns="0" bIns="0" rtlCol="0" anchor="ctr"/>
-          <a:lstStyle/>
-          <a:p>
-            <a:pPr indent="0" marL="0">
-              <a:buNone/>
-            </a:pPr>
-            <a:r>
-              <a:rPr lang="en-US" sz="1100" b="1" dirty="0">
-                <a:solidFill>
-                  <a:srgbClr val="F8F7F4">
-                    <a:alpha val="86000"/>
-                  </a:srgbClr>
-                </a:solidFill>
-                <a:latin typeface="Calibri" pitchFamily="34" charset="0"/>
-                <a:ea typeface="Calibri" pitchFamily="34" charset="-122"/>
-                <a:cs typeface="Calibri" pitchFamily="34" charset="-120"/>
-              </a:rPr>
-              <a:t>Foresight</a:t>
-            </a:r>
-            <a:endParaRPr lang="en-US" sz="1100" dirty="0"/>
-          </a:p>
-        </p:txBody>
-      </p:sp>
-      <p:sp>
-        <p:nvSpPr>
-          <p:cNvPr id="57" name="Text 55"/>
-          <p:cNvSpPr/>
-          <p:nvPr/>
-        </p:nvSpPr>
-        <p:spPr>
-          <a:xfrm>
-            <a:off x="7178040" y="1609344"/>
-            <a:ext cx="1143000" cy="274320"/>
-          </a:xfrm>
-          <a:prstGeom prst="rect">
-            <a:avLst/>
-          </a:prstGeom>
-          <a:noFill/>
-          <a:ln/>
-        </p:spPr>
-        <p:txBody>
-          <a:bodyPr wrap="square" lIns="0" tIns="0" rIns="0" bIns="0" rtlCol="0" anchor="ctr"/>
-          <a:lstStyle/>
-          <a:p>
-            <a:pPr algn="r" indent="0" marL="0">
-              <a:buNone/>
-            </a:pPr>
-            <a:r>
-              <a:rPr lang="en-US" sz="1100" b="1" dirty="0">
-                <a:solidFill>
-                  <a:srgbClr val="F8F7F4">
-                    <a:alpha val="82000"/>
-                  </a:srgbClr>
-                </a:solidFill>
-                <a:latin typeface="Cambria" pitchFamily="34" charset="0"/>
-                <a:ea typeface="Cambria" pitchFamily="34" charset="-122"/>
-                <a:cs typeface="Cambria" pitchFamily="34" charset="-120"/>
-              </a:rPr>
-              <a:t>$250K/yr</a:t>
-            </a:r>
-            <a:endParaRPr lang="en-US" sz="1100" dirty="0"/>
-          </a:p>
-        </p:txBody>
-      </p:sp>
-      <p:sp>
-        <p:nvSpPr>
-          <p:cNvPr id="58" name="Text 56"/>
-          <p:cNvSpPr/>
-          <p:nvPr/>
-        </p:nvSpPr>
-        <p:spPr>
-          <a:xfrm>
-            <a:off x="5623560" y="1920240"/>
-            <a:ext cx="1280160" cy="274320"/>
-          </a:xfrm>
-          <a:prstGeom prst="rect">
-            <a:avLst/>
-          </a:prstGeom>
-          <a:noFill/>
-          <a:ln/>
-        </p:spPr>
-        <p:txBody>
-          <a:bodyPr wrap="square" lIns="0" tIns="0" rIns="0" bIns="0" rtlCol="0" anchor="ctr"/>
-          <a:lstStyle/>
-          <a:p>
-            <a:pPr indent="0" marL="0">
-              <a:buNone/>
-            </a:pPr>
-            <a:r>
-              <a:rPr lang="en-US" sz="1100" b="1" dirty="0">
-                <a:solidFill>
-                  <a:srgbClr val="2B8A6E">
-                    <a:alpha val="86000"/>
-                  </a:srgbClr>
-                </a:solidFill>
-                <a:latin typeface="Calibri" pitchFamily="34" charset="0"/>
-                <a:ea typeface="Calibri" pitchFamily="34" charset="-122"/>
-                <a:cs typeface="Calibri" pitchFamily="34" charset="-120"/>
-              </a:rPr>
-              <a:t>Enterprise</a:t>
-            </a:r>
-            <a:endParaRPr lang="en-US" sz="1100" dirty="0"/>
-          </a:p>
-        </p:txBody>
-      </p:sp>
-      <p:sp>
-        <p:nvSpPr>
-          <p:cNvPr id="59" name="Text 57"/>
-          <p:cNvSpPr/>
-          <p:nvPr/>
-        </p:nvSpPr>
-        <p:spPr>
-          <a:xfrm>
-            <a:off x="7178040" y="1920240"/>
-            <a:ext cx="1143000" cy="274320"/>
-          </a:xfrm>
-          <a:prstGeom prst="rect">
-            <a:avLst/>
-          </a:prstGeom>
-          <a:noFill/>
-          <a:ln/>
-        </p:spPr>
-        <p:txBody>
-          <a:bodyPr wrap="square" lIns="0" tIns="0" rIns="0" bIns="0" rtlCol="0" anchor="ctr"/>
-          <a:lstStyle/>
-          <a:p>
-            <a:pPr algn="r" indent="0" marL="0">
-              <a:buNone/>
-            </a:pPr>
-            <a:r>
-              <a:rPr lang="en-US" sz="1100" b="1" dirty="0">
-                <a:solidFill>
-                  <a:srgbClr val="2B8A6E">
-                    <a:alpha val="82000"/>
-                  </a:srgbClr>
-                </a:solidFill>
-                <a:latin typeface="Cambria" pitchFamily="34" charset="0"/>
-                <a:ea typeface="Cambria" pitchFamily="34" charset="-122"/>
-                <a:cs typeface="Cambria" pitchFamily="34" charset="-120"/>
-              </a:rPr>
-              <a:t>$450K/yr</a:t>
-            </a:r>
-            <a:endParaRPr lang="en-US" sz="1100" dirty="0"/>
-          </a:p>
-        </p:txBody>
-      </p:sp>
-      <p:sp>
-        <p:nvSpPr>
-          <p:cNvPr id="60" name="Text 58"/>
-          <p:cNvSpPr/>
-          <p:nvPr/>
-        </p:nvSpPr>
-        <p:spPr>
-          <a:xfrm>
-            <a:off x="5623560" y="2267712"/>
-            <a:ext cx="3017520" cy="347472"/>
-          </a:xfrm>
-          <a:prstGeom prst="rect">
-            <a:avLst/>
-          </a:prstGeom>
-          <a:noFill/>
-          <a:ln/>
-        </p:spPr>
-        <p:txBody>
-          <a:bodyPr wrap="square" lIns="0" tIns="0" rIns="0" bIns="0" rtlCol="0" anchor="ctr"/>
-          <a:lstStyle/>
-          <a:p>
-            <a:pPr indent="0" marL="0">
-              <a:buNone/>
-            </a:pPr>
-            <a:r>
-              <a:rPr lang="en-US" sz="850" i="1" dirty="0">
-                <a:solidFill>
-                  <a:srgbClr val="F8F7F4">
-                    <a:alpha val="50000"/>
-                  </a:srgbClr>
-                </a:solidFill>
-                <a:latin typeface="Calibri" pitchFamily="34" charset="0"/>
-                <a:ea typeface="Calibri" pitchFamily="34" charset="-122"/>
-                <a:cs typeface="Calibri" pitchFamily="34" charset="-120"/>
-              </a:rPr>
-              <a:t>Annual price — stays constant until customer</a:t>
-            </a:r>
-            <a:endParaRPr lang="en-US" sz="850" dirty="0"/>
-          </a:p>
-          <a:p>
-            <a:pPr indent="0" marL="0">
-              <a:buNone/>
-            </a:pPr>
-            <a:r>
-              <a:rPr lang="en-US" sz="850" i="1" dirty="0">
-                <a:solidFill>
-                  <a:srgbClr val="F8F7F4">
-                    <a:alpha val="50000"/>
-                  </a:srgbClr>
-                </a:solidFill>
-                <a:latin typeface="Calibri" pitchFamily="34" charset="0"/>
-                <a:ea typeface="Calibri" pitchFamily="34" charset="-122"/>
-                <a:cs typeface="Calibri" pitchFamily="34" charset="-120"/>
-              </a:rPr>
-              <a:t>chooses to upgrade for more capability.</a:t>
-            </a:r>
-            <a:endParaRPr lang="en-US" sz="850" dirty="0"/>
-          </a:p>
-        </p:txBody>
-      </p:sp>
-      <p:sp>
-        <p:nvSpPr>
-          <p:cNvPr id="61" name="Shape 59"/>
-          <p:cNvSpPr/>
-          <p:nvPr/>
-        </p:nvSpPr>
-        <p:spPr>
-          <a:xfrm>
-            <a:off x="411480" y="2724912"/>
-            <a:ext cx="8366760" cy="1298448"/>
-          </a:xfrm>
-          <a:prstGeom prst="roundRect">
-            <a:avLst>
-              <a:gd name="adj" fmla="val 7042"/>
-            </a:avLst>
-          </a:prstGeom>
-          <a:solidFill>
-            <a:srgbClr val="100C22"/>
-          </a:solidFill>
-          <a:ln w="27940">
-            <a:solidFill>
-              <a:srgbClr val="C9A84C"/>
-            </a:solidFill>
-            <a:prstDash val="solid"/>
-          </a:ln>
-        </p:spPr>
-        <p:txBody>
-          <a:bodyPr/>
-          <a:p/>
-        </p:txBody>
-      </p:sp>
-      <p:sp>
-        <p:nvSpPr>
-          <p:cNvPr id="62" name="Text 60"/>
-          <p:cNvSpPr/>
-          <p:nvPr/>
-        </p:nvSpPr>
-        <p:spPr>
-          <a:xfrm>
-            <a:off x="594360" y="2798064"/>
-            <a:ext cx="7955280" cy="237744"/>
-          </a:xfrm>
-          <a:prstGeom prst="rect">
-            <a:avLst/>
-          </a:prstGeom>
-          <a:noFill/>
-          <a:ln/>
-        </p:spPr>
-        <p:txBody>
-          <a:bodyPr wrap="square" lIns="0" tIns="0" rIns="0" bIns="0" rtlCol="0" anchor="ctr"/>
-          <a:lstStyle/>
-          <a:p>
-            <a:pPr indent="0" marL="0">
-              <a:buNone/>
-            </a:pPr>
-            <a:r>
-              <a:rPr lang="en-US" sz="800" b="1" dirty="0">
-                <a:solidFill>
-                  <a:srgbClr val="C9A84C">
-                    <a:alpha val="80000"/>
-                  </a:srgbClr>
-                </a:solidFill>
-                <a:latin typeface="Calibri" pitchFamily="34" charset="0"/>
-                <a:ea typeface="Calibri" pitchFamily="34" charset="-122"/>
-                <a:cs typeface="Calibri" pitchFamily="34" charset="-120"/>
-              </a:rPr>
-              <a:t>FOUNDING PARTNER  —  THE ENTRY POINT</a:t>
-            </a:r>
-            <a:endParaRPr lang="en-US" sz="800" dirty="0"/>
-          </a:p>
-        </p:txBody>
-      </p:sp>
-      <p:sp>
-        <p:nvSpPr>
-          <p:cNvPr id="63" name="Text 61"/>
-          <p:cNvSpPr/>
-          <p:nvPr/>
-        </p:nvSpPr>
-        <p:spPr>
-          <a:xfrm>
-            <a:off x="411480" y="2999232"/>
-            <a:ext cx="3200400" cy="777240"/>
-          </a:xfrm>
-          <a:prstGeom prst="rect">
-            <a:avLst/>
-          </a:prstGeom>
-          <a:noFill/>
-          <a:ln/>
-        </p:spPr>
-        <p:txBody>
-          <a:bodyPr wrap="square" lIns="0" tIns="0" rIns="0" bIns="0" rtlCol="0" anchor="ctr"/>
-          <a:lstStyle/>
-          <a:p>
-            <a:pPr algn="ctr" indent="0" marL="0">
-              <a:buNone/>
-            </a:pPr>
-            <a:r>
-              <a:rPr lang="en-US" sz="6200" b="1" dirty="0">
-                <a:solidFill>
-                  <a:srgbClr val="C9A84C"/>
-                </a:solidFill>
-                <a:latin typeface="Cambria" pitchFamily="34" charset="0"/>
-                <a:ea typeface="Cambria" pitchFamily="34" charset="-122"/>
-                <a:cs typeface="Cambria" pitchFamily="34" charset="-120"/>
-              </a:rPr>
-              <a:t>$75K</a:t>
-            </a:r>
-            <a:endParaRPr lang="en-US" sz="6200" dirty="0"/>
-          </a:p>
-        </p:txBody>
-      </p:sp>
-      <p:sp>
-        <p:nvSpPr>
-          <p:cNvPr id="64" name="Text 62"/>
-          <p:cNvSpPr/>
-          <p:nvPr/>
-        </p:nvSpPr>
-        <p:spPr>
-          <a:xfrm>
-            <a:off x="3749040" y="3054096"/>
-            <a:ext cx="4846320" cy="274320"/>
-          </a:xfrm>
-          <a:prstGeom prst="rect">
-            <a:avLst/>
-          </a:prstGeom>
-          <a:noFill/>
-          <a:ln/>
-        </p:spPr>
-        <p:txBody>
-          <a:bodyPr wrap="square" lIns="0" tIns="0" rIns="0" bIns="0" rtlCol="0" anchor="ctr"/>
-          <a:lstStyle/>
-          <a:p>
-            <a:pPr indent="0" marL="0">
-              <a:buNone/>
-            </a:pPr>
-            <a:r>
-              <a:rPr lang="en-US" sz="1400" b="1" dirty="0">
-                <a:solidFill>
-                  <a:srgbClr val="F8F7F4">
-                    <a:alpha val="90000"/>
-                  </a:srgbClr>
-                </a:solidFill>
-                <a:latin typeface="Calibri" pitchFamily="34" charset="0"/>
-                <a:ea typeface="Calibri" pitchFamily="34" charset="-122"/>
-                <a:cs typeface="Calibri" pitchFamily="34" charset="-120"/>
-              </a:rPr>
-              <a:t>90-day validation partnership</a:t>
-            </a:r>
-            <a:endParaRPr lang="en-US" sz="1400" dirty="0"/>
-          </a:p>
-        </p:txBody>
-      </p:sp>
-      <p:sp>
-        <p:nvSpPr>
-          <p:cNvPr id="65" name="Text 63"/>
-          <p:cNvSpPr/>
-          <p:nvPr/>
-        </p:nvSpPr>
-        <p:spPr>
-          <a:xfrm>
-            <a:off x="3749040" y="3364992"/>
-            <a:ext cx="4846320" cy="237744"/>
-          </a:xfrm>
-          <a:prstGeom prst="rect">
-            <a:avLst/>
-          </a:prstGeom>
-          <a:noFill/>
-          <a:ln/>
-        </p:spPr>
-        <p:txBody>
-          <a:bodyPr wrap="square" lIns="0" tIns="0" rIns="0" bIns="0" rtlCol="0" anchor="ctr"/>
-          <a:lstStyle/>
-          <a:p>
-            <a:pPr indent="0" marL="0">
-              <a:buNone/>
-            </a:pPr>
-            <a:r>
-              <a:rPr lang="en-US" sz="1150" dirty="0">
-                <a:solidFill>
-                  <a:srgbClr val="F8F7F4">
-                    <a:alpha val="65000"/>
-                  </a:srgbClr>
-                </a:solidFill>
-                <a:latin typeface="Calibri" pitchFamily="34" charset="0"/>
-                <a:ea typeface="Calibri" pitchFamily="34" charset="-122"/>
-                <a:cs typeface="Calibri" pitchFamily="34" charset="-120"/>
-              </a:rPr>
-              <a:t>100% credited to Year 1  ·  Full platform access from Day 1</a:t>
-            </a:r>
-            <a:endParaRPr lang="en-US" sz="1150" dirty="0"/>
-          </a:p>
-        </p:txBody>
-      </p:sp>
-      <p:sp>
-        <p:nvSpPr>
-          <p:cNvPr id="66" name="Text 64"/>
-          <p:cNvSpPr/>
-          <p:nvPr/>
-        </p:nvSpPr>
-        <p:spPr>
-          <a:xfrm>
-            <a:off x="3749040" y="3621024"/>
-            <a:ext cx="4846320" cy="201168"/>
-          </a:xfrm>
-          <a:prstGeom prst="rect">
-            <a:avLst/>
-          </a:prstGeom>
-          <a:noFill/>
-          <a:ln/>
-        </p:spPr>
-        <p:txBody>
-          <a:bodyPr wrap="square" lIns="0" tIns="0" rIns="0" bIns="0" rtlCol="0" anchor="ctr"/>
-          <a:lstStyle/>
-          <a:p>
-            <a:pPr indent="0" marL="0">
-              <a:buNone/>
-            </a:pPr>
-            <a:r>
-              <a:rPr lang="en-US" sz="1050" dirty="0">
-                <a:solidFill>
-                  <a:srgbClr val="2B8A6E">
-                    <a:alpha val="78000"/>
-                  </a:srgbClr>
-                </a:solidFill>
-                <a:latin typeface="Calibri" pitchFamily="34" charset="0"/>
-                <a:ea typeface="Calibri" pitchFamily="34" charset="-122"/>
-                <a:cs typeface="Calibri" pitchFamily="34" charset="-120"/>
-              </a:rPr>
-              <a:t>Founding Partners shape the product roadmap and pricing structure.</a:t>
-            </a:r>
-            <a:endParaRPr lang="en-US" sz="1050" dirty="0"/>
-          </a:p>
-        </p:txBody>
-      </p:sp>
-      <p:sp>
-        <p:nvSpPr>
-          <p:cNvPr id="67" name="Shape 65"/>
-          <p:cNvSpPr/>
-          <p:nvPr/>
-        </p:nvSpPr>
-        <p:spPr>
-          <a:xfrm>
-            <a:off x="411480" y="4160520"/>
-            <a:ext cx="4160520" cy="731520"/>
-          </a:xfrm>
-          <a:prstGeom prst="roundRect">
-            <a:avLst>
-              <a:gd name="adj" fmla="val 8750"/>
-            </a:avLst>
-          </a:prstGeom>
-          <a:solidFill>
-            <a:srgbClr val="080D20"/>
-          </a:solidFill>
-          <a:ln w="6350">
-            <a:solidFill>
-              <a:srgbClr val="C9A84C">
-                <a:alpha val="50000"/>
-              </a:srgbClr>
-            </a:solidFill>
-            <a:prstDash val="solid"/>
-          </a:ln>
-        </p:spPr>
-        <p:txBody>
-          <a:bodyPr/>
-          <a:p/>
-        </p:txBody>
-      </p:sp>
-      <p:sp>
-        <p:nvSpPr>
-          <p:cNvPr id="68" name="Text 66"/>
-          <p:cNvSpPr/>
-          <p:nvPr/>
-        </p:nvSpPr>
-        <p:spPr>
-          <a:xfrm>
-            <a:off x="548640" y="4224528"/>
-            <a:ext cx="3840480" cy="182880"/>
-          </a:xfrm>
-          <a:prstGeom prst="rect">
-            <a:avLst/>
-          </a:prstGeom>
-          <a:noFill/>
-          <a:ln/>
-        </p:spPr>
-        <p:txBody>
-          <a:bodyPr wrap="square" lIns="0" tIns="0" rIns="0" bIns="0" rtlCol="0" anchor="ctr"/>
-          <a:lstStyle/>
-          <a:p>
-            <a:pPr indent="0" marL="0">
-              <a:buNone/>
-            </a:pPr>
-            <a:r>
-              <a:rPr lang="en-US" sz="700" b="1" dirty="0">
-                <a:solidFill>
-                  <a:srgbClr val="C9A84C">
-                    <a:alpha val="65000"/>
-                  </a:srgbClr>
-                </a:solidFill>
-                <a:latin typeface="Calibri" pitchFamily="34" charset="0"/>
-                <a:ea typeface="Calibri" pitchFamily="34" charset="-122"/>
-                <a:cs typeface="Calibri" pitchFamily="34" charset="-120"/>
-              </a:rPr>
-              <a:t>5-YEAR LTV</a:t>
-            </a:r>
-            <a:endParaRPr lang="en-US" sz="700" dirty="0"/>
-          </a:p>
-        </p:txBody>
-      </p:sp>
-      <p:sp>
-        <p:nvSpPr>
-          <p:cNvPr id="69" name="Text 67"/>
-          <p:cNvSpPr/>
-          <p:nvPr/>
-        </p:nvSpPr>
-        <p:spPr>
-          <a:xfrm>
-            <a:off x="548640" y="4425696"/>
-            <a:ext cx="1828800" cy="237744"/>
-          </a:xfrm>
-          <a:prstGeom prst="rect">
-            <a:avLst/>
-          </a:prstGeom>
-          <a:noFill/>
-          <a:ln/>
-        </p:spPr>
-        <p:txBody>
-          <a:bodyPr wrap="square" lIns="0" tIns="0" rIns="0" bIns="0" rtlCol="0" anchor="ctr"/>
-          <a:lstStyle/>
-          <a:p>
-            <a:pPr indent="0" marL="0">
-              <a:buNone/>
-            </a:pPr>
-            <a:r>
-              <a:rPr lang="en-US" sz="1100" dirty="0">
-                <a:solidFill>
-                  <a:srgbClr val="F8F7F4">
-                    <a:alpha val="68000"/>
-                  </a:srgbClr>
-                </a:solidFill>
-                <a:latin typeface="Calibri" pitchFamily="34" charset="0"/>
-                <a:ea typeface="Calibri" pitchFamily="34" charset="-122"/>
-                <a:cs typeface="Calibri" pitchFamily="34" charset="-120"/>
-              </a:rPr>
-              <a:t>Core customer</a:t>
-            </a:r>
-            <a:endParaRPr lang="en-US" sz="1100" dirty="0"/>
-          </a:p>
-        </p:txBody>
-      </p:sp>
-      <p:sp>
-        <p:nvSpPr>
-          <p:cNvPr id="70" name="Text 68"/>
-          <p:cNvSpPr/>
-          <p:nvPr/>
-        </p:nvSpPr>
-        <p:spPr>
-          <a:xfrm>
-            <a:off x="2423160" y="4425696"/>
-            <a:ext cx="1097280" cy="237744"/>
-          </a:xfrm>
-          <a:prstGeom prst="rect">
-            <a:avLst/>
-          </a:prstGeom>
-          <a:noFill/>
-          <a:ln/>
-        </p:spPr>
-        <p:txBody>
-          <a:bodyPr wrap="square" lIns="0" tIns="0" rIns="0" bIns="0" rtlCol="0" anchor="ctr"/>
-          <a:lstStyle/>
-          <a:p>
-            <a:pPr algn="r" indent="0" marL="0">
-              <a:buNone/>
-            </a:pPr>
-            <a:r>
-              <a:rPr lang="en-US" sz="1100" b="1" dirty="0">
-                <a:solidFill>
-                  <a:srgbClr val="F8F7F4">
-                    <a:alpha val="80000"/>
-                  </a:srgbClr>
-                </a:solidFill>
-                <a:latin typeface="Cambria" pitchFamily="34" charset="0"/>
-                <a:ea typeface="Cambria" pitchFamily="34" charset="-122"/>
-                <a:cs typeface="Cambria" pitchFamily="34" charset="-120"/>
-              </a:rPr>
-              <a:t>$750K</a:t>
-            </a:r>
-            <a:endParaRPr lang="en-US" sz="1100" dirty="0"/>
-          </a:p>
-        </p:txBody>
-      </p:sp>
-      <p:sp>
-        <p:nvSpPr>
-          <p:cNvPr id="71" name="Text 69"/>
-          <p:cNvSpPr/>
-          <p:nvPr/>
-        </p:nvSpPr>
-        <p:spPr>
-          <a:xfrm>
-            <a:off x="548640" y="4663440"/>
-            <a:ext cx="1828800" cy="237744"/>
-          </a:xfrm>
-          <a:prstGeom prst="rect">
-            <a:avLst/>
-          </a:prstGeom>
-          <a:noFill/>
-          <a:ln/>
-        </p:spPr>
-        <p:txBody>
-          <a:bodyPr wrap="square" lIns="0" tIns="0" rIns="0" bIns="0" rtlCol="0" anchor="ctr"/>
-          <a:lstStyle/>
-          <a:p>
-            <a:pPr indent="0" marL="0">
-              <a:buNone/>
-            </a:pPr>
-            <a:r>
-              <a:rPr lang="en-US" sz="1100" b="1" dirty="0">
-                <a:solidFill>
-                  <a:srgbClr val="2B8A6E">
-                    <a:alpha val="90000"/>
-                  </a:srgbClr>
-                </a:solidFill>
-                <a:latin typeface="Calibri" pitchFamily="34" charset="0"/>
-                <a:ea typeface="Calibri" pitchFamily="34" charset="-122"/>
-                <a:cs typeface="Calibri" pitchFamily="34" charset="-120"/>
-              </a:rPr>
-              <a:t>Enterprise</a:t>
-            </a:r>
-            <a:endParaRPr lang="en-US" sz="1100" dirty="0"/>
-          </a:p>
-        </p:txBody>
-      </p:sp>
-      <p:sp>
-        <p:nvSpPr>
-          <p:cNvPr id="72" name="Text 70"/>
-          <p:cNvSpPr/>
-          <p:nvPr/>
-        </p:nvSpPr>
-        <p:spPr>
-          <a:xfrm>
-            <a:off x="2423160" y="4663440"/>
-            <a:ext cx="1097280" cy="237744"/>
-          </a:xfrm>
-          <a:prstGeom prst="rect">
-            <a:avLst/>
-          </a:prstGeom>
-          <a:noFill/>
-          <a:ln/>
-        </p:spPr>
-        <p:txBody>
-          <a:bodyPr wrap="square" lIns="0" tIns="0" rIns="0" bIns="0" rtlCol="0" anchor="ctr"/>
-          <a:lstStyle/>
-          <a:p>
-            <a:pPr algn="r" indent="0" marL="0">
-              <a:buNone/>
-            </a:pPr>
-            <a:r>
-              <a:rPr lang="en-US" sz="1300" b="1" dirty="0">
-                <a:solidFill>
-                  <a:srgbClr val="C9A84C">
-                    <a:alpha val="95000"/>
-                  </a:srgbClr>
-                </a:solidFill>
-                <a:latin typeface="Cambria" pitchFamily="34" charset="0"/>
-                <a:ea typeface="Cambria" pitchFamily="34" charset="-122"/>
-                <a:cs typeface="Cambria" pitchFamily="34" charset="-120"/>
-              </a:rPr>
-              <a:t>$2.0M+</a:t>
-            </a:r>
-            <a:endParaRPr lang="en-US" sz="1300" dirty="0"/>
-          </a:p>
-        </p:txBody>
-      </p:sp>
-      <p:sp>
-        <p:nvSpPr>
-          <p:cNvPr id="73" name="Shape 71"/>
-          <p:cNvSpPr/>
-          <p:nvPr/>
-        </p:nvSpPr>
-        <p:spPr>
-          <a:xfrm>
-            <a:off x="4754880" y="4160520"/>
-            <a:ext cx="4023360" cy="384048"/>
-          </a:xfrm>
-          <a:prstGeom prst="roundRect">
-            <a:avLst>
-              <a:gd name="adj" fmla="val 14286"/>
-            </a:avLst>
-          </a:prstGeom>
-          <a:solidFill>
-            <a:srgbClr val="0D0820"/>
-          </a:solidFill>
-          <a:ln w="12700">
-            <a:solidFill>
-              <a:srgbClr val="C9A84C">
-                <a:alpha val="78000"/>
-              </a:srgbClr>
-            </a:solidFill>
-            <a:prstDash val="solid"/>
-          </a:ln>
-        </p:spPr>
-        <p:txBody>
-          <a:bodyPr/>
-          <a:p/>
-        </p:txBody>
-      </p:sp>
-      <p:sp>
-        <p:nvSpPr>
-          <p:cNvPr id="74" name="Text 72"/>
-          <p:cNvSpPr/>
-          <p:nvPr/>
-        </p:nvSpPr>
-        <p:spPr>
-          <a:xfrm>
-            <a:off x="4754880" y="4160520"/>
-            <a:ext cx="4023360" cy="384048"/>
-          </a:xfrm>
-          <a:prstGeom prst="rect">
-            <a:avLst/>
-          </a:prstGeom>
-          <a:noFill/>
-          <a:ln/>
-        </p:spPr>
-        <p:txBody>
-          <a:bodyPr wrap="square" lIns="0" tIns="0" rIns="0" bIns="0" rtlCol="0" anchor="ctr"/>
-          <a:lstStyle/>
-          <a:p>
-            <a:pPr algn="ctr" indent="0" marL="0">
-              <a:buNone/>
-            </a:pPr>
-            <a:r>
-              <a:rPr lang="en-US" sz="1000" dirty="0">
-                <a:solidFill>
-                  <a:srgbClr val="F8F7F4"/>
-                </a:solidFill>
-                <a:latin typeface="Calibri" pitchFamily="34" charset="0"/>
-                <a:ea typeface="Calibri" pitchFamily="34" charset="-122"/>
-                <a:cs typeface="Calibri" pitchFamily="34" charset="-120"/>
-              </a:rPr>
-              <a:t>2026 COHORT  ·  </a:t>
-            </a:r>
-            <a:pPr algn="ctr" indent="0" marL="0">
-              <a:buNone/>
-            </a:pPr>
-            <a:r>
-              <a:rPr lang="en-US" sz="1200" b="1" dirty="0">
-                <a:solidFill>
-                  <a:srgbClr val="C9A84C"/>
-                </a:solidFill>
-                <a:latin typeface="Calibri" pitchFamily="34" charset="0"/>
-                <a:ea typeface="Calibri" pitchFamily="34" charset="-122"/>
-                <a:cs typeface="Calibri" pitchFamily="34" charset="-120"/>
-              </a:rPr>
-              <a:t>12 SEATS</a:t>
-            </a:r>
-            <a:pPr algn="ctr" indent="0" marL="0">
-              <a:buNone/>
-            </a:pPr>
-            <a:r>
-              <a:rPr lang="en-US" sz="1000" dirty="0">
-                <a:solidFill>
-                  <a:srgbClr val="F8F7F4"/>
-                </a:solidFill>
-                <a:latin typeface="Calibri" pitchFamily="34" charset="0"/>
-                <a:ea typeface="Calibri" pitchFamily="34" charset="-122"/>
-                <a:cs typeface="Calibri" pitchFamily="34" charset="-120"/>
-              </a:rPr>
-              <a:t>  ·  APPLICATIONS OPEN NOW</a:t>
-            </a:r>
-            <a:endParaRPr lang="en-US" sz="1000" dirty="0"/>
-          </a:p>
-        </p:txBody>
-      </p:sp>
-      <p:sp>
-        <p:nvSpPr>
-          <p:cNvPr id="75" name="Text 73"/>
-          <p:cNvSpPr/>
-          <p:nvPr/>
-        </p:nvSpPr>
-        <p:spPr>
-          <a:xfrm>
-            <a:off x="4754880" y="4626864"/>
-            <a:ext cx="2560320" cy="256032"/>
-          </a:xfrm>
-          <a:prstGeom prst="rect">
-            <a:avLst/>
-          </a:prstGeom>
-          <a:noFill/>
-          <a:ln/>
-        </p:spPr>
-        <p:txBody>
-          <a:bodyPr wrap="square" lIns="0" tIns="0" rIns="0" bIns="0" rtlCol="0" anchor="ctr"/>
-          <a:lstStyle/>
-          <a:p>
-            <a:pPr algn="ctr" indent="0" marL="0">
-              <a:buNone/>
-            </a:pPr>
-            <a:r>
-              <a:rPr lang="en-US" sz="1400" b="1" dirty="0">
-                <a:solidFill>
-                  <a:srgbClr val="C9A84C"/>
-                </a:solidFill>
-                <a:latin typeface="Cambria" pitchFamily="34" charset="0"/>
-                <a:ea typeface="Cambria" pitchFamily="34" charset="-122"/>
-                <a:cs typeface="Cambria" pitchFamily="34" charset="-120"/>
-              </a:rPr>
-              <a:t>vaughnmartin.com</a:t>
-            </a:r>
-            <a:endParaRPr lang="en-US" sz="1400" dirty="0"/>
-          </a:p>
-        </p:txBody>
-      </p:sp>
-      <p:sp>
-        <p:nvSpPr>
-          <p:cNvPr id="76" name="Text 74"/>
-          <p:cNvSpPr/>
-          <p:nvPr/>
-        </p:nvSpPr>
-        <p:spPr>
-          <a:xfrm>
-            <a:off x="4754880" y="4882896"/>
-            <a:ext cx="2560320" cy="182880"/>
-          </a:xfrm>
-          <a:prstGeom prst="rect">
-            <a:avLst/>
-          </a:prstGeom>
-          <a:noFill/>
-          <a:ln/>
-        </p:spPr>
-        <p:txBody>
-          <a:bodyPr wrap="square" lIns="0" tIns="0" rIns="0" bIns="0" rtlCol="0" anchor="ctr"/>
-          <a:lstStyle/>
-          <a:p>
-            <a:pPr algn="ctr" indent="0" marL="0">
-              <a:buNone/>
-            </a:pPr>
-            <a:r>
-              <a:rPr lang="en-US" sz="900" dirty="0">
-                <a:solidFill>
-                  <a:srgbClr val="F8F7F4">
-                    <a:alpha val="60000"/>
-                  </a:srgbClr>
-                </a:solidFill>
-                <a:latin typeface="Calibri" pitchFamily="34" charset="0"/>
-                <a:ea typeface="Calibri" pitchFamily="34" charset="-122"/>
-                <a:cs typeface="Calibri" pitchFamily="34" charset="-120"/>
-              </a:rPr>
-              <a:t>founding@vaughnmartin.com</a:t>
-            </a:r>
-            <a:endParaRPr lang="en-US" sz="900" dirty="0"/>
+          <a:ln>
+            <a:noFill/>
+          </a:ln>
+        </p:spPr>
+        <p:style>
+          <a:lnRef idx="1">
+            <a:schemeClr val="accent1"/>
+          </a:lnRef>
+          <a:fillRef idx="3">
+            <a:schemeClr val="accent1"/>
+          </a:fillRef>
+          <a:effectRef idx="2">
+            <a:schemeClr val="accent1"/>
+          </a:effectRef>
+          <a:fontRef idx="minor">
+            <a:schemeClr val="lt1"/>
+          </a:fontRef>
+        </p:style>
+        <p:txBody>
+          <a:bodyPr rtlCol="0" anchor="ctr"/>
+          <a:lstStyle/>
+          <a:p>
+            <a:pPr algn="ctr"/>
+          </a:p>
+        </p:txBody>
+      </p:sp>
+      <p:sp>
+        <p:nvSpPr>
+          <p:cNvPr id="13" name="TextBox 12"/>
+          <p:cNvSpPr txBox="1"/>
+          <p:nvPr/>
+        </p:nvSpPr>
+        <p:spPr>
+          <a:xfrm>
+            <a:off x="822960" y="4206240"/>
+            <a:ext cx="7498079" cy="347472"/>
+          </a:xfrm>
+          <a:prstGeom prst="rect">
+            <a:avLst/>
+          </a:prstGeom>
+          <a:noFill/>
+        </p:spPr>
+        <p:txBody>
+          <a:bodyPr wrap="square">
+            <a:spAutoFit/>
+          </a:bodyPr>
+          <a:lstStyle/>
+          <a:p>
+            <a:pPr algn="l"/>
+            <a:r>
+              <a:rPr sz="900" b="0" i="0">
+                <a:solidFill>
+                  <a:srgbClr val="CCCCCC"/>
+                </a:solidFill>
+                <a:latin typeface="Barlow"/>
+              </a:rPr>
+              <a:t>An independent Fortune 50 operator — with no commercial relationship — spent 4 weeks reviewing the platform and staked her professional reputation on a public endorsement. That is not a customer quote. That is external validation of the thesis.</a:t>
+            </a:r>
           </a:p>
         </p:txBody>
       </p:sp>

</xml_diff>